<commit_message>
Fix slide 9 row overlap + tighten slide 6 chips
- slide_phase1: content-driven row heights instead of equal division
  (Scope's 6 bullets were bleeding into Timeline/Fee rows)
- slide_experience: lens chips now sized to text content; added missing
  "Composable interface primitives" caption beneath chips

Co-Authored-By: Claude Opus 4.7 <noreply@anthropic.com>
</commit_message>
<xml_diff>
--- a/sf-civic-art-map.pptx
+++ b/sf-civic-art-map.pptx
@@ -5458,8 +5458,8 @@
         </p:nvSpPr>
         <p:spPr>
           <a:xfrm>
-            <a:off x="3549243" y="6263640"/>
-            <a:ext cx="960120" cy="292608"/>
+            <a:off x="4174337" y="6126480"/>
+            <a:ext cx="492760" cy="274320"/>
           </a:xfrm>
           <a:prstGeom prst="roundRect">
             <a:avLst>
@@ -5491,7 +5491,7 @@
           </a:fontRef>
         </p:style>
         <p:txBody>
-          <a:bodyPr rtlCol="0" anchor="ctr" lIns="25400" rIns="25400" tIns="0" bIns="0"/>
+          <a:bodyPr rtlCol="0" anchor="ctr" lIns="50800" rIns="50800" tIns="0" bIns="0"/>
           <a:lstStyle/>
           <a:p>
             <a:pPr algn="l"/>
@@ -5515,8 +5515,8 @@
         </p:nvSpPr>
         <p:spPr>
           <a:xfrm>
-            <a:off x="4582515" y="6263640"/>
-            <a:ext cx="960120" cy="292608"/>
+            <a:off x="4758537" y="6126480"/>
+            <a:ext cx="782320" cy="274320"/>
           </a:xfrm>
           <a:prstGeom prst="roundRect">
             <a:avLst>
@@ -5548,7 +5548,7 @@
           </a:fontRef>
         </p:style>
         <p:txBody>
-          <a:bodyPr rtlCol="0" anchor="ctr" lIns="25400" rIns="25400" tIns="0" bIns="0"/>
+          <a:bodyPr rtlCol="0" anchor="ctr" lIns="50800" rIns="50800" tIns="0" bIns="0"/>
           <a:lstStyle/>
           <a:p>
             <a:pPr algn="l"/>
@@ -5572,8 +5572,8 @@
         </p:nvSpPr>
         <p:spPr>
           <a:xfrm>
-            <a:off x="5615787" y="6263640"/>
-            <a:ext cx="960120" cy="292608"/>
+            <a:off x="5632297" y="6126480"/>
+            <a:ext cx="492760" cy="274320"/>
           </a:xfrm>
           <a:prstGeom prst="roundRect">
             <a:avLst>
@@ -5605,7 +5605,7 @@
           </a:fontRef>
         </p:style>
         <p:txBody>
-          <a:bodyPr rtlCol="0" anchor="ctr" lIns="25400" rIns="25400" tIns="0" bIns="0"/>
+          <a:bodyPr rtlCol="0" anchor="ctr" lIns="50800" rIns="50800" tIns="0" bIns="0"/>
           <a:lstStyle/>
           <a:p>
             <a:pPr algn="l"/>
@@ -5629,8 +5629,8 @@
         </p:nvSpPr>
         <p:spPr>
           <a:xfrm>
-            <a:off x="6649059" y="6263640"/>
-            <a:ext cx="960120" cy="292608"/>
+            <a:off x="6216497" y="6126480"/>
+            <a:ext cx="999490" cy="274320"/>
           </a:xfrm>
           <a:prstGeom prst="roundRect">
             <a:avLst>
@@ -5662,7 +5662,7 @@
           </a:fontRef>
         </p:style>
         <p:txBody>
-          <a:bodyPr rtlCol="0" anchor="ctr" lIns="25400" rIns="25400" tIns="0" bIns="0"/>
+          <a:bodyPr rtlCol="0" anchor="ctr" lIns="50800" rIns="50800" tIns="0" bIns="0"/>
           <a:lstStyle/>
           <a:p>
             <a:pPr algn="l"/>
@@ -5686,8 +5686,8 @@
         </p:nvSpPr>
         <p:spPr>
           <a:xfrm>
-            <a:off x="7682331" y="6263640"/>
-            <a:ext cx="960120" cy="292608"/>
+            <a:off x="7307427" y="6126480"/>
+            <a:ext cx="709930" cy="274320"/>
           </a:xfrm>
           <a:prstGeom prst="roundRect">
             <a:avLst>
@@ -5719,7 +5719,7 @@
           </a:fontRef>
         </p:style>
         <p:txBody>
-          <a:bodyPr rtlCol="0" anchor="ctr" lIns="25400" rIns="25400" tIns="0" bIns="0"/>
+          <a:bodyPr rtlCol="0" anchor="ctr" lIns="50800" rIns="50800" tIns="0" bIns="0"/>
           <a:lstStyle/>
           <a:p>
             <a:pPr algn="l"/>
@@ -5731,6 +5731,41 @@
                 <a:latin typeface="JetBrains Mono"/>
               </a:rPr>
               <a:t>Network</a:t>
+            </a:r>
+          </a:p>
+        </p:txBody>
+      </p:sp>
+      <p:sp>
+        <p:nvSpPr>
+          <p:cNvPr id="11" name="TextBox 10"/>
+          <p:cNvSpPr txBox="1"/>
+          <p:nvPr/>
+        </p:nvSpPr>
+        <p:spPr>
+          <a:xfrm>
+            <a:off x="640080" y="6510528"/>
+            <a:ext cx="10911535" cy="274320"/>
+          </a:xfrm>
+          <a:prstGeom prst="rect">
+            <a:avLst/>
+          </a:prstGeom>
+          <a:noFill/>
+        </p:spPr>
+        <p:txBody>
+          <a:bodyPr wrap="square" lIns="0" rIns="0" tIns="0" bIns="0" anchor="t">
+            <a:spAutoFit/>
+          </a:bodyPr>
+          <a:lstStyle/>
+          <a:p>
+            <a:pPr algn="l"/>
+            <a:r>
+              <a:rPr sz="1100" b="0" i="1">
+                <a:solidFill>
+                  <a:srgbClr val="5C6577"/>
+                </a:solidFill>
+                <a:latin typeface="Inter"/>
+              </a:rPr>
+              <a:t>Composable interface primitives that combine into emergent journeys.</a:t>
             </a:r>
           </a:p>
         </p:txBody>
@@ -6812,7 +6847,7 @@
         <p:spPr>
           <a:xfrm>
             <a:off x="640080" y="502920"/>
-            <a:ext cx="10911535" cy="1920240"/>
+            <a:ext cx="10911535" cy="2194560"/>
           </a:xfrm>
           <a:prstGeom prst="rect">
             <a:avLst/>
@@ -6882,8 +6917,8 @@
         </p:nvSpPr>
         <p:spPr>
           <a:xfrm>
-            <a:off x="640080" y="3657600"/>
-            <a:ext cx="10911535" cy="2926080"/>
+            <a:off x="640080" y="3246120"/>
+            <a:ext cx="10911535" cy="3012694"/>
           </a:xfrm>
           <a:prstGeom prst="rect">
             <a:avLst/>
@@ -6928,8 +6963,8 @@
         </p:nvSpPr>
         <p:spPr>
           <a:xfrm>
-            <a:off x="804672" y="3749040"/>
-            <a:ext cx="1828800" cy="457200"/>
+            <a:off x="804672" y="3410712"/>
+            <a:ext cx="1828800" cy="1005840"/>
           </a:xfrm>
           <a:prstGeom prst="rect">
             <a:avLst/>
@@ -6963,8 +6998,8 @@
         </p:nvSpPr>
         <p:spPr>
           <a:xfrm>
-            <a:off x="2816352" y="3749040"/>
-            <a:ext cx="8570671" cy="457200"/>
+            <a:off x="2862072" y="3410712"/>
+            <a:ext cx="8524951" cy="1005840"/>
           </a:xfrm>
           <a:prstGeom prst="rect">
             <a:avLst/>
@@ -6979,7 +7014,7 @@
           <a:p>
             <a:pPr algn="l">
               <a:spcAft>
-                <a:spcPts val="100"/>
+                <a:spcPts val="200"/>
               </a:spcAft>
             </a:pPr>
             <a:r>
@@ -7004,7 +7039,7 @@
           <a:p>
             <a:pPr algn="l">
               <a:spcAft>
-                <a:spcPts val="100"/>
+                <a:spcPts val="200"/>
               </a:spcAft>
             </a:pPr>
             <a:r>
@@ -7029,7 +7064,7 @@
           <a:p>
             <a:pPr algn="l">
               <a:spcAft>
-                <a:spcPts val="100"/>
+                <a:spcPts val="200"/>
               </a:spcAft>
             </a:pPr>
             <a:r>
@@ -7054,7 +7089,7 @@
           <a:p>
             <a:pPr algn="l">
               <a:spcAft>
-                <a:spcPts val="100"/>
+                <a:spcPts val="200"/>
               </a:spcAft>
             </a:pPr>
             <a:r>
@@ -7079,7 +7114,7 @@
           <a:p>
             <a:pPr algn="l">
               <a:spcAft>
-                <a:spcPts val="100"/>
+                <a:spcPts val="200"/>
               </a:spcAft>
             </a:pPr>
             <a:r>
@@ -7104,7 +7139,7 @@
           <a:p>
             <a:pPr algn="l">
               <a:spcAft>
-                <a:spcPts val="100"/>
+                <a:spcPts val="200"/>
               </a:spcAft>
             </a:pPr>
             <a:r>
@@ -7136,8 +7171,8 @@
         </p:nvSpPr>
         <p:spPr>
           <a:xfrm>
-            <a:off x="804672" y="4169664"/>
-            <a:ext cx="10582351" cy="9525"/>
+            <a:off x="804672" y="4416552"/>
+            <a:ext cx="10582351" cy="6350"/>
           </a:xfrm>
           <a:prstGeom prst="rect">
             <a:avLst/>
@@ -7180,8 +7215,8 @@
         </p:nvSpPr>
         <p:spPr>
           <a:xfrm>
-            <a:off x="804672" y="4206240"/>
-            <a:ext cx="1828800" cy="457200"/>
+            <a:off x="804672" y="4422902"/>
+            <a:ext cx="1828800" cy="274320"/>
           </a:xfrm>
           <a:prstGeom prst="rect">
             <a:avLst/>
@@ -7215,8 +7250,8 @@
         </p:nvSpPr>
         <p:spPr>
           <a:xfrm>
-            <a:off x="2816352" y="4206240"/>
-            <a:ext cx="8570671" cy="457200"/>
+            <a:off x="2862072" y="4422902"/>
+            <a:ext cx="8524951" cy="274320"/>
           </a:xfrm>
           <a:prstGeom prst="rect">
             <a:avLst/>
@@ -7250,8 +7285,8 @@
         </p:nvSpPr>
         <p:spPr>
           <a:xfrm>
-            <a:off x="804672" y="4626864"/>
-            <a:ext cx="10582351" cy="9525"/>
+            <a:off x="804672" y="4697222"/>
+            <a:ext cx="10582351" cy="6350"/>
           </a:xfrm>
           <a:prstGeom prst="rect">
             <a:avLst/>
@@ -7294,8 +7329,8 @@
         </p:nvSpPr>
         <p:spPr>
           <a:xfrm>
-            <a:off x="804672" y="4663440"/>
-            <a:ext cx="1828800" cy="457200"/>
+            <a:off x="804672" y="4703572"/>
+            <a:ext cx="1828800" cy="274320"/>
           </a:xfrm>
           <a:prstGeom prst="rect">
             <a:avLst/>
@@ -7329,8 +7364,8 @@
         </p:nvSpPr>
         <p:spPr>
           <a:xfrm>
-            <a:off x="2816352" y="4663440"/>
-            <a:ext cx="8570671" cy="457200"/>
+            <a:off x="2862072" y="4703572"/>
+            <a:ext cx="8524951" cy="274320"/>
           </a:xfrm>
           <a:prstGeom prst="rect">
             <a:avLst/>
@@ -7364,8 +7399,8 @@
         </p:nvSpPr>
         <p:spPr>
           <a:xfrm>
-            <a:off x="804672" y="5084064"/>
-            <a:ext cx="10582351" cy="9525"/>
+            <a:off x="804672" y="4977892"/>
+            <a:ext cx="10582351" cy="6350"/>
           </a:xfrm>
           <a:prstGeom prst="rect">
             <a:avLst/>
@@ -7408,8 +7443,8 @@
         </p:nvSpPr>
         <p:spPr>
           <a:xfrm>
-            <a:off x="804672" y="5120640"/>
-            <a:ext cx="1828800" cy="457200"/>
+            <a:off x="804672" y="4984242"/>
+            <a:ext cx="1828800" cy="274320"/>
           </a:xfrm>
           <a:prstGeom prst="rect">
             <a:avLst/>
@@ -7443,8 +7478,8 @@
         </p:nvSpPr>
         <p:spPr>
           <a:xfrm>
-            <a:off x="2816352" y="5120640"/>
-            <a:ext cx="8570671" cy="457200"/>
+            <a:off x="2862072" y="4984242"/>
+            <a:ext cx="8524951" cy="274320"/>
           </a:xfrm>
           <a:prstGeom prst="rect">
             <a:avLst/>
@@ -7478,8 +7513,8 @@
         </p:nvSpPr>
         <p:spPr>
           <a:xfrm>
-            <a:off x="804672" y="5541264"/>
-            <a:ext cx="10582351" cy="9525"/>
+            <a:off x="804672" y="5258562"/>
+            <a:ext cx="10582351" cy="6350"/>
           </a:xfrm>
           <a:prstGeom prst="rect">
             <a:avLst/>
@@ -7522,8 +7557,8 @@
         </p:nvSpPr>
         <p:spPr>
           <a:xfrm>
-            <a:off x="804672" y="5577840"/>
-            <a:ext cx="1828800" cy="457200"/>
+            <a:off x="804672" y="5264912"/>
+            <a:ext cx="1828800" cy="365760"/>
           </a:xfrm>
           <a:prstGeom prst="rect">
             <a:avLst/>
@@ -7557,8 +7592,8 @@
         </p:nvSpPr>
         <p:spPr>
           <a:xfrm>
-            <a:off x="2816352" y="5577840"/>
-            <a:ext cx="8570671" cy="457200"/>
+            <a:off x="2862072" y="5264912"/>
+            <a:ext cx="8524951" cy="365760"/>
           </a:xfrm>
           <a:prstGeom prst="rect">
             <a:avLst/>
@@ -7592,8 +7627,8 @@
         </p:nvSpPr>
         <p:spPr>
           <a:xfrm>
-            <a:off x="804672" y="5998464"/>
-            <a:ext cx="10582351" cy="9525"/>
+            <a:off x="804672" y="5630672"/>
+            <a:ext cx="10582351" cy="6350"/>
           </a:xfrm>
           <a:prstGeom prst="rect">
             <a:avLst/>
@@ -7636,7 +7671,7 @@
         </p:nvSpPr>
         <p:spPr>
           <a:xfrm>
-            <a:off x="804672" y="6035040"/>
+            <a:off x="804672" y="5637022"/>
             <a:ext cx="1828800" cy="457200"/>
           </a:xfrm>
           <a:prstGeom prst="rect">
@@ -7671,8 +7706,8 @@
         </p:nvSpPr>
         <p:spPr>
           <a:xfrm>
-            <a:off x="2816352" y="6035040"/>
-            <a:ext cx="8570671" cy="457200"/>
+            <a:off x="2862072" y="5637022"/>
+            <a:ext cx="8524951" cy="457200"/>
           </a:xfrm>
           <a:prstGeom prst="rect">
             <a:avLst/>

</xml_diff>

<commit_message>
Slides v3: web-matching type scale + brand strip + italic accent
- Add brand strip "SAN FRANCISCO · CIVIC ART MAP" at top of every slide
- Bump h1 to 48pt with italic-accent "civic art utility" matching the web
- Bump h2's to 32pt throughout (was 22-26pt)
- Larger body/dek/card text matching the web's clamp() values
- Wider container, tighter content spacing throughout

Co-Authored-By: Claude Opus 4.7 <noreply@anthropic.com>
</commit_message>
<xml_diff>
--- a/sf-civic-art-map.pptx
+++ b/sf-civic-art-map.pptx
@@ -3113,8 +3113,8 @@
         </p:nvSpPr>
         <p:spPr>
           <a:xfrm>
-            <a:off x="1295247" y="1097280"/>
-            <a:ext cx="9601200" cy="4937760"/>
+            <a:off x="777240" y="274320"/>
+            <a:ext cx="7315200" cy="320040"/>
           </a:xfrm>
           <a:prstGeom prst="rect">
             <a:avLst/>
@@ -3127,81 +3127,243 @@
           </a:bodyPr>
           <a:lstStyle/>
           <a:p>
+            <a:pPr algn="l"/>
+            <a:r>
+              <a:rPr sz="1100" b="1" i="0" spc="300">
+                <a:solidFill>
+                  <a:srgbClr val="0E1B36"/>
+                </a:solidFill>
+                <a:latin typeface="JetBrains Mono"/>
+              </a:rPr>
+              <a:t>SAN FRANCISCO · CIVIC ART MAP</a:t>
+            </a:r>
+          </a:p>
+        </p:txBody>
+      </p:sp>
+      <p:sp>
+        <p:nvSpPr>
+          <p:cNvPr id="3" name="Rectangle 2"/>
+          <p:cNvSpPr/>
+          <p:nvPr/>
+        </p:nvSpPr>
+        <p:spPr>
+          <a:xfrm>
+            <a:off x="0" y="749808"/>
+            <a:ext cx="12191695" cy="9525"/>
+          </a:xfrm>
+          <a:prstGeom prst="rect">
+            <a:avLst/>
+          </a:prstGeom>
+          <a:solidFill>
+            <a:srgbClr val="D6DEEA"/>
+          </a:solidFill>
+          <a:ln>
+            <a:noFill/>
+          </a:ln>
+          <a:effectLst/>
+        </p:spPr>
+        <p:style>
+          <a:lnRef idx="1">
+            <a:schemeClr val="accent1"/>
+          </a:lnRef>
+          <a:fillRef idx="3">
+            <a:schemeClr val="accent1"/>
+          </a:fillRef>
+          <a:effectRef idx="2">
+            <a:schemeClr val="accent1"/>
+          </a:effectRef>
+          <a:fontRef idx="minor">
+            <a:schemeClr val="lt1"/>
+          </a:fontRef>
+        </p:style>
+        <p:txBody>
+          <a:bodyPr rtlCol="0" anchor="ctr"/>
+          <a:lstStyle/>
+          <a:p>
+            <a:pPr algn="ctr"/>
+          </a:p>
+        </p:txBody>
+      </p:sp>
+      <p:sp>
+        <p:nvSpPr>
+          <p:cNvPr id="4" name="TextBox 3"/>
+          <p:cNvSpPr txBox="1"/>
+          <p:nvPr/>
+        </p:nvSpPr>
+        <p:spPr>
+          <a:xfrm>
+            <a:off x="777240" y="1325880"/>
+            <a:ext cx="10637215" cy="292608"/>
+          </a:xfrm>
+          <a:prstGeom prst="rect">
+            <a:avLst/>
+          </a:prstGeom>
+          <a:noFill/>
+        </p:spPr>
+        <p:txBody>
+          <a:bodyPr wrap="square" lIns="0" rIns="0" tIns="0" bIns="0" anchor="t">
+            <a:spAutoFit/>
+          </a:bodyPr>
+          <a:lstStyle/>
+          <a:p>
+            <a:pPr algn="l"/>
+            <a:r>
+              <a:rPr sz="1100" b="1" i="0" spc="350">
+                <a:solidFill>
+                  <a:srgbClr val="1F3D88"/>
+                </a:solidFill>
+                <a:latin typeface="JetBrains Mono"/>
+              </a:rPr>
+              <a:t>A PROPOSAL FOR ANDY AND DEBORAH RAPPAPORT</a:t>
+            </a:r>
+          </a:p>
+        </p:txBody>
+      </p:sp>
+      <p:sp>
+        <p:nvSpPr>
+          <p:cNvPr id="5" name="TextBox 4"/>
+          <p:cNvSpPr txBox="1"/>
+          <p:nvPr/>
+        </p:nvSpPr>
+        <p:spPr>
+          <a:xfrm>
+            <a:off x="777240" y="1783080"/>
+            <a:ext cx="10637215" cy="2926080"/>
+          </a:xfrm>
+          <a:prstGeom prst="rect">
+            <a:avLst/>
+          </a:prstGeom>
+          <a:noFill/>
+        </p:spPr>
+        <p:txBody>
+          <a:bodyPr wrap="square" lIns="0" rIns="0" tIns="0" bIns="0" anchor="t">
+            <a:spAutoFit/>
+          </a:bodyPr>
+          <a:lstStyle/>
+          <a:p>
             <a:pPr algn="l">
-              <a:spcAft>
-                <a:spcPts val="1400"/>
-              </a:spcAft>
+              <a:lnSpc>
+                <a:spcPct val="106000"/>
+              </a:lnSpc>
             </a:pPr>
             <a:r>
-              <a:rPr sz="1100" b="1" i="0" spc="240">
+              <a:rPr sz="4800" b="0" i="0">
+                <a:solidFill>
+                  <a:srgbClr val="0E1B36"/>
+                </a:solidFill>
+                <a:latin typeface="Cormorant Garamond"/>
+              </a:rPr>
+              <a:t>A </a:t>
+            </a:r>
+            <a:r>
+              <a:rPr sz="4800" b="0" i="1">
                 <a:solidFill>
                   <a:srgbClr val="1F3D88"/>
                 </a:solidFill>
+                <a:latin typeface="Cormorant Garamond"/>
+              </a:rPr>
+              <a:t>civic art utility</a:t>
+            </a:r>
+            <a:r>
+              <a:rPr sz="4800" b="0" i="0">
+                <a:solidFill>
+                  <a:srgbClr val="0E1B36"/>
+                </a:solidFill>
+                <a:latin typeface="Cormorant Garamond"/>
+              </a:rPr>
+              <a:t> for San Francisco—enriching, beautifully made, and built as a laboratory for the next generation of cultural infrastructure.</a:t>
+            </a:r>
+          </a:p>
+        </p:txBody>
+      </p:sp>
+      <p:sp>
+        <p:nvSpPr>
+          <p:cNvPr id="6" name="TextBox 5"/>
+          <p:cNvSpPr txBox="1"/>
+          <p:nvPr/>
+        </p:nvSpPr>
+        <p:spPr>
+          <a:xfrm>
+            <a:off x="777240" y="4846320"/>
+            <a:ext cx="10637215" cy="1188720"/>
+          </a:xfrm>
+          <a:prstGeom prst="rect">
+            <a:avLst/>
+          </a:prstGeom>
+          <a:noFill/>
+        </p:spPr>
+        <p:txBody>
+          <a:bodyPr wrap="square" lIns="0" rIns="0" tIns="0" bIns="0" anchor="t">
+            <a:spAutoFit/>
+          </a:bodyPr>
+          <a:lstStyle/>
+          <a:p>
+            <a:pPr algn="l">
+              <a:lnSpc>
+                <a:spcPct val="142000"/>
+              </a:lnSpc>
+            </a:pPr>
+            <a:r>
+              <a:rPr sz="1500" b="0" i="0">
+                <a:solidFill>
+                  <a:srgbClr val="1C2638"/>
+                </a:solidFill>
+                <a:latin typeface="Inter"/>
+              </a:rPr>
+              <a:t>San Francisco has one of the greatest art ecosystems in the country and one of the hardest to navigate. The opportunity is a single, comprehensive cultural utility for the city—built with care, run in the public interest, and designed as a shared working environment for the people, institutions, and technologies that could make San Francisco the most rewarding place in the world to encounter art.</a:t>
+            </a:r>
+          </a:p>
+        </p:txBody>
+      </p:sp>
+      <p:sp>
+        <p:nvSpPr>
+          <p:cNvPr id="7" name="TextBox 6"/>
+          <p:cNvSpPr txBox="1"/>
+          <p:nvPr/>
+        </p:nvSpPr>
+        <p:spPr>
+          <a:xfrm>
+            <a:off x="777240" y="6217920"/>
+            <a:ext cx="10637215" cy="320040"/>
+          </a:xfrm>
+          <a:prstGeom prst="rect">
+            <a:avLst/>
+          </a:prstGeom>
+          <a:noFill/>
+        </p:spPr>
+        <p:txBody>
+          <a:bodyPr wrap="square" lIns="0" rIns="0" tIns="0" bIns="0" anchor="ctr">
+            <a:spAutoFit/>
+          </a:bodyPr>
+          <a:lstStyle/>
+          <a:p>
+            <a:pPr algn="l"/>
+            <a:r>
+              <a:rPr sz="1000" b="0" i="0" spc="250">
+                <a:solidFill>
+                  <a:srgbClr val="5C6577"/>
+                </a:solidFill>
                 <a:latin typeface="JetBrains Mono"/>
               </a:rPr>
-              <a:t>A PROPOSAL FOR ANDY AND DEBORAH RAPPAPORT</a:t>
-            </a:r>
-          </a:p>
-          <a:p>
-            <a:pPr algn="l">
-              <a:spcAft>
-                <a:spcPts val="1800"/>
-              </a:spcAft>
-            </a:pPr>
-            <a:r>
-              <a:rPr sz="3400" b="0" i="0">
-                <a:solidFill>
-                  <a:srgbClr val="0E1B36"/>
-                </a:solidFill>
-                <a:latin typeface="Cormorant Garamond"/>
-              </a:rPr>
-              <a:t>A civic art utility for San Francisco—enriching, beautifully made, and built as a laboratory for the next generation of cultural infrastructure.</a:t>
-            </a:r>
-          </a:p>
-          <a:p>
-            <a:pPr algn="l">
-              <a:spcAft>
-                <a:spcPts val="2000"/>
-              </a:spcAft>
-            </a:pPr>
-            <a:r>
-              <a:rPr sz="1500" b="0" i="0">
-                <a:solidFill>
-                  <a:srgbClr val="1C2638"/>
-                </a:solidFill>
-                <a:latin typeface="Inter"/>
-              </a:rPr>
-              <a:t>San Francisco has one of the greatest art ecosystems in the country and one of the hardest to navigate. The opportunity is a single, comprehensive cultural utility for the city—built with care, run in the public interest, and designed as a shared working environment for the people, institutions, and technologies that could make San Francisco the most rewarding place in the world to encounter art.</a:t>
-            </a:r>
-          </a:p>
-          <a:p>
-            <a:pPr algn="l"/>
-            <a:r>
-              <a:rPr sz="1000" b="0" i="0" spc="160">
+              <a:t>PREPARED BY </a:t>
+            </a:r>
+            <a:r>
+              <a:rPr sz="1000" b="1" i="0" spc="250">
+                <a:solidFill>
+                  <a:srgbClr val="1F3D88"/>
+                </a:solidFill>
+                <a:latin typeface="JetBrains Mono"/>
+              </a:rPr>
+              <a:t>ANDREW GOLDSTEIN</a:t>
+            </a:r>
+            <a:r>
+              <a:rPr sz="1000" b="0" i="0" spc="250">
                 <a:solidFill>
                   <a:srgbClr val="5C6577"/>
                 </a:solidFill>
                 <a:latin typeface="JetBrains Mono"/>
               </a:rPr>
-              <a:t>Prepared by </a:t>
-            </a:r>
-            <a:r>
-              <a:rPr sz="1000" b="1" i="0" spc="160">
-                <a:solidFill>
-                  <a:srgbClr val="1F3D88"/>
-                </a:solidFill>
-                <a:latin typeface="JetBrains Mono"/>
-              </a:rPr>
-              <a:t>ANDREW GOLDSTEIN</a:t>
-            </a:r>
-            <a:r>
-              <a:rPr sz="1000" b="0" i="0" spc="160">
-                <a:solidFill>
-                  <a:srgbClr val="5C6577"/>
-                </a:solidFill>
-                <a:latin typeface="JetBrains Mono"/>
-              </a:rPr>
-              <a:t> · Dedalus Media Architects · May 2026</a:t>
+              <a:t> · DEDALUS MEDIA ARCHITECTS · MAY 2026</a:t>
             </a:r>
           </a:p>
         </p:txBody>
@@ -3240,8 +3402,8 @@
         </p:nvSpPr>
         <p:spPr>
           <a:xfrm>
-            <a:off x="2438247" y="2057400"/>
-            <a:ext cx="7315200" cy="2743200"/>
+            <a:off x="777240" y="274320"/>
+            <a:ext cx="7315200" cy="320040"/>
           </a:xfrm>
           <a:prstGeom prst="rect">
             <a:avLst/>
@@ -3254,9 +3416,88 @@
           </a:bodyPr>
           <a:lstStyle/>
           <a:p>
+            <a:pPr algn="l"/>
+            <a:r>
+              <a:rPr sz="1100" b="1" i="0" spc="300">
+                <a:solidFill>
+                  <a:srgbClr val="0E1B36"/>
+                </a:solidFill>
+                <a:latin typeface="JetBrains Mono"/>
+              </a:rPr>
+              <a:t>SAN FRANCISCO · CIVIC ART MAP</a:t>
+            </a:r>
+          </a:p>
+        </p:txBody>
+      </p:sp>
+      <p:sp>
+        <p:nvSpPr>
+          <p:cNvPr id="3" name="Rectangle 2"/>
+          <p:cNvSpPr/>
+          <p:nvPr/>
+        </p:nvSpPr>
+        <p:spPr>
+          <a:xfrm>
+            <a:off x="0" y="749808"/>
+            <a:ext cx="12191695" cy="9525"/>
+          </a:xfrm>
+          <a:prstGeom prst="rect">
+            <a:avLst/>
+          </a:prstGeom>
+          <a:solidFill>
+            <a:srgbClr val="D6DEEA"/>
+          </a:solidFill>
+          <a:ln>
+            <a:noFill/>
+          </a:ln>
+          <a:effectLst/>
+        </p:spPr>
+        <p:style>
+          <a:lnRef idx="1">
+            <a:schemeClr val="accent1"/>
+          </a:lnRef>
+          <a:fillRef idx="3">
+            <a:schemeClr val="accent1"/>
+          </a:fillRef>
+          <a:effectRef idx="2">
+            <a:schemeClr val="accent1"/>
+          </a:effectRef>
+          <a:fontRef idx="minor">
+            <a:schemeClr val="lt1"/>
+          </a:fontRef>
+        </p:style>
+        <p:txBody>
+          <a:bodyPr rtlCol="0" anchor="ctr"/>
+          <a:lstStyle/>
+          <a:p>
             <a:pPr algn="ctr"/>
-            <a:r>
-              <a:rPr sz="8000" b="0" i="0">
+          </a:p>
+        </p:txBody>
+      </p:sp>
+      <p:sp>
+        <p:nvSpPr>
+          <p:cNvPr id="4" name="TextBox 3"/>
+          <p:cNvSpPr txBox="1"/>
+          <p:nvPr/>
+        </p:nvSpPr>
+        <p:spPr>
+          <a:xfrm>
+            <a:off x="1523847" y="1828800"/>
+            <a:ext cx="9144000" cy="3200400"/>
+          </a:xfrm>
+          <a:prstGeom prst="rect">
+            <a:avLst/>
+          </a:prstGeom>
+          <a:noFill/>
+        </p:spPr>
+        <p:txBody>
+          <a:bodyPr wrap="square" lIns="0" rIns="0" tIns="0" bIns="0" anchor="ctr">
+            <a:spAutoFit/>
+          </a:bodyPr>
+          <a:lstStyle/>
+          <a:p>
+            <a:pPr algn="ctr"/>
+            <a:r>
+              <a:rPr sz="9600" b="0" i="0">
                 <a:solidFill>
                   <a:srgbClr val="0E1B36"/>
                 </a:solidFill>
@@ -3301,8 +3542,87 @@
         </p:nvSpPr>
         <p:spPr>
           <a:xfrm>
-            <a:off x="640080" y="502920"/>
-            <a:ext cx="10911535" cy="5852160"/>
+            <a:off x="777240" y="274320"/>
+            <a:ext cx="7315200" cy="320040"/>
+          </a:xfrm>
+          <a:prstGeom prst="rect">
+            <a:avLst/>
+          </a:prstGeom>
+          <a:noFill/>
+        </p:spPr>
+        <p:txBody>
+          <a:bodyPr wrap="square" lIns="0" rIns="0" tIns="0" bIns="0" anchor="ctr">
+            <a:spAutoFit/>
+          </a:bodyPr>
+          <a:lstStyle/>
+          <a:p>
+            <a:pPr algn="l"/>
+            <a:r>
+              <a:rPr sz="1100" b="1" i="0" spc="300">
+                <a:solidFill>
+                  <a:srgbClr val="0E1B36"/>
+                </a:solidFill>
+                <a:latin typeface="JetBrains Mono"/>
+              </a:rPr>
+              <a:t>SAN FRANCISCO · CIVIC ART MAP</a:t>
+            </a:r>
+          </a:p>
+        </p:txBody>
+      </p:sp>
+      <p:sp>
+        <p:nvSpPr>
+          <p:cNvPr id="3" name="Rectangle 2"/>
+          <p:cNvSpPr/>
+          <p:nvPr/>
+        </p:nvSpPr>
+        <p:spPr>
+          <a:xfrm>
+            <a:off x="0" y="749808"/>
+            <a:ext cx="12191695" cy="9525"/>
+          </a:xfrm>
+          <a:prstGeom prst="rect">
+            <a:avLst/>
+          </a:prstGeom>
+          <a:solidFill>
+            <a:srgbClr val="D6DEEA"/>
+          </a:solidFill>
+          <a:ln>
+            <a:noFill/>
+          </a:ln>
+          <a:effectLst/>
+        </p:spPr>
+        <p:style>
+          <a:lnRef idx="1">
+            <a:schemeClr val="accent1"/>
+          </a:lnRef>
+          <a:fillRef idx="3">
+            <a:schemeClr val="accent1"/>
+          </a:fillRef>
+          <a:effectRef idx="2">
+            <a:schemeClr val="accent1"/>
+          </a:effectRef>
+          <a:fontRef idx="minor">
+            <a:schemeClr val="lt1"/>
+          </a:fontRef>
+        </p:style>
+        <p:txBody>
+          <a:bodyPr rtlCol="0" anchor="ctr"/>
+          <a:lstStyle/>
+          <a:p>
+            <a:pPr algn="ctr"/>
+          </a:p>
+        </p:txBody>
+      </p:sp>
+      <p:sp>
+        <p:nvSpPr>
+          <p:cNvPr id="4" name="TextBox 3"/>
+          <p:cNvSpPr txBox="1"/>
+          <p:nvPr/>
+        </p:nvSpPr>
+        <p:spPr>
+          <a:xfrm>
+            <a:off x="777240" y="1097280"/>
+            <a:ext cx="10637215" cy="1920240"/>
           </a:xfrm>
           <a:prstGeom prst="rect">
             <a:avLst/>
@@ -3332,25 +3652,85 @@
           </a:p>
           <a:p>
             <a:pPr algn="l">
-              <a:spcAft>
-                <a:spcPts val="1400"/>
-              </a:spcAft>
+              <a:lnSpc>
+                <a:spcPct val="114000"/>
+              </a:lnSpc>
             </a:pPr>
             <a:r>
-              <a:rPr sz="2400" b="0" i="0">
+              <a:rPr sz="3200" b="0" i="0">
                 <a:solidFill>
                   <a:srgbClr val="0E1B36"/>
                 </a:solidFill>
                 <a:latin typeface="Cormorant Garamond"/>
               </a:rPr>
-              <a:t>An art map for San Francisco that feels like the city itself—inspiring, generous, delightful, and unafraid of beauty.</a:t>
-            </a:r>
-          </a:p>
+              <a:t>An art map for San Francisco that feels like the city itself—</a:t>
+            </a:r>
+            <a:r>
+              <a:rPr sz="3200" b="0" i="1">
+                <a:solidFill>
+                  <a:srgbClr val="0E1B36"/>
+                </a:solidFill>
+                <a:latin typeface="Cormorant Garamond"/>
+              </a:rPr>
+              <a:t>inspiring, generous, delightful, and unafraid of beauty</a:t>
+            </a:r>
+            <a:r>
+              <a:rPr sz="3200" b="0" i="0">
+                <a:solidFill>
+                  <a:srgbClr val="0E1B36"/>
+                </a:solidFill>
+                <a:latin typeface="Cormorant Garamond"/>
+              </a:rPr>
+              <a:t>.</a:t>
+            </a:r>
+          </a:p>
+        </p:txBody>
+      </p:sp>
+      <p:sp>
+        <p:nvSpPr>
+          <p:cNvPr id="5" name="TextBox 4"/>
+          <p:cNvSpPr txBox="1"/>
+          <p:nvPr/>
+        </p:nvSpPr>
+        <p:spPr>
+          <a:xfrm>
+            <a:off x="777240" y="3291840"/>
+            <a:ext cx="10637215" cy="2194560"/>
+          </a:xfrm>
+          <a:prstGeom prst="rect">
+            <a:avLst/>
+          </a:prstGeom>
+          <a:noFill/>
+        </p:spPr>
+        <p:txBody>
+          <a:bodyPr wrap="square" lIns="0" rIns="0" tIns="0" bIns="0" anchor="t">
+            <a:spAutoFit/>
+          </a:bodyPr>
+          <a:lstStyle/>
           <a:p>
             <a:pPr algn="l">
-              <a:spcAft>
+              <a:lnSpc>
+                <a:spcPct val="150000"/>
+              </a:lnSpc>
+            </a:pPr>
+            <a:r>
+              <a:rPr sz="1300" b="0" i="0">
+                <a:solidFill>
+                  <a:srgbClr val="1C2638"/>
+                </a:solidFill>
+                <a:latin typeface="Inter"/>
+              </a:rPr>
+              <a:t>For all the energy in the city's cultural life, there is no comprehensive way to find and engage with it. Museums, galleries, pop-ups, artist studios, public art, AR and digital-art activations all coexist, but none are legible to one another—let alone to the local audience or curious visitor.</a:t>
+            </a:r>
+          </a:p>
+          <a:p>
+            <a:pPr algn="l">
+              <a:lnSpc>
+                <a:spcPct val="150000"/>
+              </a:lnSpc>
+              <a:spcBef>
                 <a:spcPts val="1000"/>
-              </a:spcAft>
+              </a:spcBef>
             </a:pPr>
             <a:r>
               <a:rPr sz="1300" b="0" i="0">
@@ -3359,22 +3739,6 @@
                 </a:solidFill>
                 <a:latin typeface="Inter"/>
               </a:rPr>
-              <a:t>For all the energy in the city's cultural life, there is no comprehensive way to find and engage with it. Museums, galleries, pop-ups, artist studios, public art, AR and digital-art activations all coexist, but none are legible to one another—let alone to the local audience or curious visitor.</a:t>
-            </a:r>
-          </a:p>
-          <a:p>
-            <a:pPr algn="l">
-              <a:spcAft>
-                <a:spcPts val="1600"/>
-              </a:spcAft>
-            </a:pPr>
-            <a:r>
-              <a:rPr sz="1300" b="0" i="0">
-                <a:solidFill>
-                  <a:srgbClr val="1C2638"/>
-                </a:solidFill>
-                <a:latin typeface="Inter"/>
-              </a:rPr>
               <a:t>This is a market-design problem. The traditional venues—galleries, museums, nonprofits—are under structural pressure. Vital newcomers—digital artists, immersive venues, AI-native creators—are operating without an infrastructure. Critics who previously served as wayfinding mechanisms have either vanished or been fragmented across algorithmic channels.</a:t>
             </a:r>
           </a:p>
@@ -3382,14 +3746,14 @@
       </p:sp>
       <p:sp>
         <p:nvSpPr>
-          <p:cNvPr id="3" name="Rectangle 2"/>
+          <p:cNvPr id="6" name="Rectangle 5"/>
           <p:cNvSpPr/>
           <p:nvPr/>
         </p:nvSpPr>
         <p:spPr>
           <a:xfrm>
-            <a:off x="640080" y="4937760"/>
-            <a:ext cx="73152" cy="1371600"/>
+            <a:off x="777240" y="5577840"/>
+            <a:ext cx="82296" cy="868680"/>
           </a:xfrm>
           <a:prstGeom prst="rect">
             <a:avLst/>
@@ -3426,14 +3790,14 @@
       </p:sp>
       <p:sp>
         <p:nvSpPr>
-          <p:cNvPr id="4" name="TextBox 3"/>
+          <p:cNvPr id="7" name="TextBox 6"/>
           <p:cNvSpPr txBox="1"/>
           <p:nvPr/>
         </p:nvSpPr>
         <p:spPr>
           <a:xfrm>
-            <a:off x="868680" y="4937760"/>
-            <a:ext cx="10682935" cy="1371600"/>
+            <a:off x="1133856" y="5577840"/>
+            <a:ext cx="10280599" cy="868680"/>
           </a:xfrm>
           <a:prstGeom prst="rect">
             <a:avLst/>
@@ -3446,9 +3810,13 @@
           </a:bodyPr>
           <a:lstStyle/>
           <a:p>
-            <a:pPr algn="l"/>
-            <a:r>
-              <a:rPr sz="2000" b="0" i="0">
+            <a:pPr algn="l">
+              <a:lnSpc>
+                <a:spcPct val="130000"/>
+              </a:lnSpc>
+            </a:pPr>
+            <a:r>
+              <a:rPr sz="2200" b="0" i="0">
                 <a:solidFill>
                   <a:srgbClr val="0E1B36"/>
                 </a:solidFill>
@@ -3493,8 +3861,8 @@
         </p:nvSpPr>
         <p:spPr>
           <a:xfrm>
-            <a:off x="640080" y="502920"/>
-            <a:ext cx="10911535" cy="1371600"/>
+            <a:off x="777240" y="274320"/>
+            <a:ext cx="7315200" cy="320040"/>
           </a:xfrm>
           <a:prstGeom prst="rect">
             <a:avLst/>
@@ -3502,124 +3870,34 @@
           <a:noFill/>
         </p:spPr>
         <p:txBody>
-          <a:bodyPr wrap="square" lIns="0" rIns="0" tIns="0" bIns="0" anchor="t">
+          <a:bodyPr wrap="square" lIns="0" rIns="0" tIns="0" bIns="0" anchor="ctr">
             <a:spAutoFit/>
           </a:bodyPr>
           <a:lstStyle/>
           <a:p>
-            <a:pPr algn="l">
-              <a:spcAft>
-                <a:spcPts val="1400"/>
-              </a:spcAft>
-            </a:pPr>
-            <a:r>
-              <a:rPr sz="1100" b="1" i="0" spc="240">
-                <a:solidFill>
-                  <a:srgbClr val="1F3D88"/>
+            <a:pPr algn="l"/>
+            <a:r>
+              <a:rPr sz="1100" b="1" i="0" spc="300">
+                <a:solidFill>
+                  <a:srgbClr val="0E1B36"/>
                 </a:solidFill>
                 <a:latin typeface="JetBrains Mono"/>
               </a:rPr>
-              <a:t>THREE COMMITMENTS SHAPE IT</a:t>
-            </a:r>
-          </a:p>
-          <a:p>
-            <a:pPr algn="l">
-              <a:spcAft>
-                <a:spcPts val="1400"/>
-              </a:spcAft>
-            </a:pPr>
-            <a:r>
-              <a:rPr sz="2400" b="0" i="0">
-                <a:solidFill>
-                  <a:srgbClr val="0E1B36"/>
-                </a:solidFill>
-                <a:latin typeface="Cormorant Garamond"/>
-              </a:rPr>
-              <a:t>A new category of cultural utility, designed by what it refuses to be.</a:t>
-            </a:r>
-          </a:p>
-        </p:txBody>
-      </p:sp>
-      <p:sp>
-        <p:nvSpPr>
-          <p:cNvPr id="3" name="TextBox 2"/>
-          <p:cNvSpPr txBox="1"/>
-          <p:nvPr/>
-        </p:nvSpPr>
-        <p:spPr>
-          <a:xfrm>
-            <a:off x="640080" y="2286000"/>
-            <a:ext cx="3383280" cy="1417320"/>
-          </a:xfrm>
-          <a:prstGeom prst="rect">
-            <a:avLst/>
-          </a:prstGeom>
-          <a:noFill/>
-        </p:spPr>
-        <p:txBody>
-          <a:bodyPr wrap="square" lIns="0" rIns="0" tIns="0" bIns="0" anchor="t">
-            <a:spAutoFit/>
-          </a:bodyPr>
-          <a:lstStyle/>
-          <a:p>
-            <a:pPr algn="l"/>
-            <a:r>
-              <a:rPr sz="2000" b="0" i="1">
-                <a:solidFill>
-                  <a:srgbClr val="1F3D88"/>
-                </a:solidFill>
-                <a:latin typeface="Cormorant Garamond"/>
-              </a:rPr>
-              <a:t>Civic, not commercial.</a:t>
-            </a:r>
-          </a:p>
-        </p:txBody>
-      </p:sp>
-      <p:sp>
-        <p:nvSpPr>
-          <p:cNvPr id="4" name="TextBox 3"/>
-          <p:cNvSpPr txBox="1"/>
-          <p:nvPr/>
-        </p:nvSpPr>
-        <p:spPr>
-          <a:xfrm>
-            <a:off x="4389120" y="2286000"/>
-            <a:ext cx="7162495" cy="1417320"/>
-          </a:xfrm>
-          <a:prstGeom prst="rect">
-            <a:avLst/>
-          </a:prstGeom>
-          <a:noFill/>
-        </p:spPr>
-        <p:txBody>
-          <a:bodyPr wrap="square" lIns="0" rIns="0" tIns="0" bIns="0" anchor="t">
-            <a:spAutoFit/>
-          </a:bodyPr>
-          <a:lstStyle/>
-          <a:p>
-            <a:pPr algn="l"/>
-            <a:r>
-              <a:rPr sz="1200" b="0" i="0">
-                <a:solidFill>
-                  <a:srgbClr val="1C2638"/>
-                </a:solidFill>
-                <a:latin typeface="Inter"/>
-              </a:rPr>
-              <a:t>Operated in the public interest, with editorial independence and a sustaining model that doesn't depend on extracting value from artists or galleries. It complements—never competes with—the institutions whose work it surfaces.</a:t>
-            </a:r>
-          </a:p>
-        </p:txBody>
-      </p:sp>
-      <p:sp>
-        <p:nvSpPr>
-          <p:cNvPr id="5" name="Rectangle 4"/>
+              <a:t>SAN FRANCISCO · CIVIC ART MAP</a:t>
+            </a:r>
+          </a:p>
+        </p:txBody>
+      </p:sp>
+      <p:sp>
+        <p:nvSpPr>
+          <p:cNvPr id="3" name="Rectangle 2"/>
           <p:cNvSpPr/>
           <p:nvPr/>
         </p:nvSpPr>
         <p:spPr>
           <a:xfrm>
-            <a:off x="640080" y="3593592"/>
-            <a:ext cx="10911535" cy="9525"/>
+            <a:off x="0" y="749808"/>
+            <a:ext cx="12191695" cy="9525"/>
           </a:xfrm>
           <a:prstGeom prst="rect">
             <a:avLst/>
@@ -3656,14 +3934,14 @@
       </p:sp>
       <p:sp>
         <p:nvSpPr>
-          <p:cNvPr id="6" name="TextBox 5"/>
+          <p:cNvPr id="4" name="TextBox 3"/>
           <p:cNvSpPr txBox="1"/>
           <p:nvPr/>
         </p:nvSpPr>
         <p:spPr>
           <a:xfrm>
-            <a:off x="640080" y="3703320"/>
-            <a:ext cx="3383280" cy="1417320"/>
+            <a:off x="777240" y="1097280"/>
+            <a:ext cx="10637215" cy="1645920"/>
           </a:xfrm>
           <a:prstGeom prst="rect">
             <a:avLst/>
@@ -3676,29 +3954,49 @@
           </a:bodyPr>
           <a:lstStyle/>
           <a:p>
-            <a:pPr algn="l"/>
-            <a:r>
-              <a:rPr sz="2000" b="0" i="1">
+            <a:pPr algn="l">
+              <a:spcAft>
+                <a:spcPts val="1400"/>
+              </a:spcAft>
+            </a:pPr>
+            <a:r>
+              <a:rPr sz="1100" b="1" i="0" spc="240">
                 <a:solidFill>
                   <a:srgbClr val="1F3D88"/>
                 </a:solidFill>
+                <a:latin typeface="JetBrains Mono"/>
+              </a:rPr>
+              <a:t>THREE COMMITMENTS SHAPE IT</a:t>
+            </a:r>
+          </a:p>
+          <a:p>
+            <a:pPr algn="l">
+              <a:spcAft>
+                <a:spcPts val="1400"/>
+              </a:spcAft>
+            </a:pPr>
+            <a:r>
+              <a:rPr sz="3200" b="0" i="0">
+                <a:solidFill>
+                  <a:srgbClr val="0E1B36"/>
+                </a:solidFill>
                 <a:latin typeface="Cormorant Garamond"/>
               </a:rPr>
-              <a:t>Beautifully made, not merely functional.</a:t>
-            </a:r>
-          </a:p>
-        </p:txBody>
-      </p:sp>
-      <p:sp>
-        <p:nvSpPr>
-          <p:cNvPr id="7" name="TextBox 6"/>
+              <a:t>A new category of cultural utility, designed by what it refuses to be.</a:t>
+            </a:r>
+          </a:p>
+        </p:txBody>
+      </p:sp>
+      <p:sp>
+        <p:nvSpPr>
+          <p:cNvPr id="5" name="TextBox 4"/>
           <p:cNvSpPr txBox="1"/>
           <p:nvPr/>
         </p:nvSpPr>
         <p:spPr>
           <a:xfrm>
-            <a:off x="4389120" y="3703320"/>
-            <a:ext cx="7162495" cy="1417320"/>
+            <a:off x="777240" y="3154680"/>
+            <a:ext cx="3291840" cy="1143000"/>
           </a:xfrm>
           <a:prstGeom prst="rect">
             <a:avLst/>
@@ -3711,29 +4009,72 @@
           </a:bodyPr>
           <a:lstStyle/>
           <a:p>
-            <a:pPr algn="l"/>
-            <a:r>
-              <a:rPr sz="1200" b="0" i="0">
+            <a:pPr algn="l">
+              <a:lnSpc>
+                <a:spcPct val="118000"/>
+              </a:lnSpc>
+            </a:pPr>
+            <a:r>
+              <a:rPr sz="2200" b="0" i="1">
+                <a:solidFill>
+                  <a:srgbClr val="1F3D88"/>
+                </a:solidFill>
+                <a:latin typeface="Cormorant Garamond"/>
+              </a:rPr>
+              <a:t>Civic, not commercial.</a:t>
+            </a:r>
+          </a:p>
+        </p:txBody>
+      </p:sp>
+      <p:sp>
+        <p:nvSpPr>
+          <p:cNvPr id="6" name="TextBox 5"/>
+          <p:cNvSpPr txBox="1"/>
+          <p:nvPr/>
+        </p:nvSpPr>
+        <p:spPr>
+          <a:xfrm>
+            <a:off x="4526280" y="3154680"/>
+            <a:ext cx="6888175" cy="1143000"/>
+          </a:xfrm>
+          <a:prstGeom prst="rect">
+            <a:avLst/>
+          </a:prstGeom>
+          <a:noFill/>
+        </p:spPr>
+        <p:txBody>
+          <a:bodyPr wrap="square" lIns="0" rIns="0" tIns="0" bIns="0" anchor="t">
+            <a:spAutoFit/>
+          </a:bodyPr>
+          <a:lstStyle/>
+          <a:p>
+            <a:pPr algn="l">
+              <a:lnSpc>
+                <a:spcPct val="145000"/>
+              </a:lnSpc>
+            </a:pPr>
+            <a:r>
+              <a:rPr sz="1300" b="0" i="0">
                 <a:solidFill>
                   <a:srgbClr val="1C2638"/>
                 </a:solidFill>
                 <a:latin typeface="Inter"/>
               </a:rPr>
-              <a:t>The interface holds itself to a standard usually reserved for cultural institutions: the care of a national-park map, the warmth of a hospitable host, the clarity of a great editorial product. San Francisco deserves nothing less than the most thoughtfully designed cultural utility any American city has built.</a:t>
-            </a:r>
-          </a:p>
-        </p:txBody>
-      </p:sp>
-      <p:sp>
-        <p:nvSpPr>
-          <p:cNvPr id="8" name="Rectangle 7"/>
+              <a:t>Operated in the public interest, with editorial independence and a sustaining model that doesn't depend on extracting value from artists or galleries. It complements—never competes with—the institutions whose work it surfaces.</a:t>
+            </a:r>
+          </a:p>
+        </p:txBody>
+      </p:sp>
+      <p:sp>
+        <p:nvSpPr>
+          <p:cNvPr id="7" name="Rectangle 6"/>
           <p:cNvSpPr/>
           <p:nvPr/>
         </p:nvSpPr>
         <p:spPr>
           <a:xfrm>
-            <a:off x="640080" y="5010912"/>
-            <a:ext cx="10911535" cy="9525"/>
+            <a:off x="777240" y="4206240"/>
+            <a:ext cx="10637215" cy="9525"/>
           </a:xfrm>
           <a:prstGeom prst="rect">
             <a:avLst/>
@@ -3770,14 +4111,14 @@
       </p:sp>
       <p:sp>
         <p:nvSpPr>
-          <p:cNvPr id="9" name="TextBox 8"/>
+          <p:cNvPr id="8" name="TextBox 7"/>
           <p:cNvSpPr txBox="1"/>
           <p:nvPr/>
         </p:nvSpPr>
         <p:spPr>
           <a:xfrm>
-            <a:off x="640080" y="5120640"/>
-            <a:ext cx="3383280" cy="1417320"/>
+            <a:off x="777240" y="4297680"/>
+            <a:ext cx="3291840" cy="1143000"/>
           </a:xfrm>
           <a:prstGeom prst="rect">
             <a:avLst/>
@@ -3790,29 +4131,33 @@
           </a:bodyPr>
           <a:lstStyle/>
           <a:p>
-            <a:pPr algn="l"/>
-            <a:r>
-              <a:rPr sz="2000" b="0" i="1">
+            <a:pPr algn="l">
+              <a:lnSpc>
+                <a:spcPct val="118000"/>
+              </a:lnSpc>
+            </a:pPr>
+            <a:r>
+              <a:rPr sz="2200" b="0" i="1">
                 <a:solidFill>
                   <a:srgbClr val="1F3D88"/>
                 </a:solidFill>
                 <a:latin typeface="Cormorant Garamond"/>
               </a:rPr>
-              <a:t>A laboratory, not a finished product.</a:t>
-            </a:r>
-          </a:p>
-        </p:txBody>
-      </p:sp>
-      <p:sp>
-        <p:nvSpPr>
-          <p:cNvPr id="10" name="TextBox 9"/>
+              <a:t>Beautifully made, not merely functional.</a:t>
+            </a:r>
+          </a:p>
+        </p:txBody>
+      </p:sp>
+      <p:sp>
+        <p:nvSpPr>
+          <p:cNvPr id="9" name="TextBox 8"/>
           <p:cNvSpPr txBox="1"/>
           <p:nvPr/>
         </p:nvSpPr>
         <p:spPr>
           <a:xfrm>
-            <a:off x="4389120" y="5120640"/>
-            <a:ext cx="7162495" cy="1417320"/>
+            <a:off x="4526280" y="4297680"/>
+            <a:ext cx="6888175" cy="1143000"/>
           </a:xfrm>
           <a:prstGeom prst="rect">
             <a:avLst/>
@@ -3825,9 +4170,135 @@
           </a:bodyPr>
           <a:lstStyle/>
           <a:p>
-            <a:pPr algn="l"/>
-            <a:r>
-              <a:rPr sz="1200" b="0" i="0">
+            <a:pPr algn="l">
+              <a:lnSpc>
+                <a:spcPct val="145000"/>
+              </a:lnSpc>
+            </a:pPr>
+            <a:r>
+              <a:rPr sz="1300" b="0" i="0">
+                <a:solidFill>
+                  <a:srgbClr val="1C2638"/>
+                </a:solidFill>
+                <a:latin typeface="Inter"/>
+              </a:rPr>
+              <a:t>The interface holds itself to a standard usually reserved for cultural institutions: the care of a national-park map, the warmth of a hospitable host, the clarity of a great editorial product. San Francisco deserves nothing less than the most thoughtfully designed cultural utility any American city has built.</a:t>
+            </a:r>
+          </a:p>
+        </p:txBody>
+      </p:sp>
+      <p:sp>
+        <p:nvSpPr>
+          <p:cNvPr id="10" name="Rectangle 9"/>
+          <p:cNvSpPr/>
+          <p:nvPr/>
+        </p:nvSpPr>
+        <p:spPr>
+          <a:xfrm>
+            <a:off x="777240" y="5349240"/>
+            <a:ext cx="10637215" cy="9525"/>
+          </a:xfrm>
+          <a:prstGeom prst="rect">
+            <a:avLst/>
+          </a:prstGeom>
+          <a:solidFill>
+            <a:srgbClr val="D6DEEA"/>
+          </a:solidFill>
+          <a:ln>
+            <a:noFill/>
+          </a:ln>
+          <a:effectLst/>
+        </p:spPr>
+        <p:style>
+          <a:lnRef idx="1">
+            <a:schemeClr val="accent1"/>
+          </a:lnRef>
+          <a:fillRef idx="3">
+            <a:schemeClr val="accent1"/>
+          </a:fillRef>
+          <a:effectRef idx="2">
+            <a:schemeClr val="accent1"/>
+          </a:effectRef>
+          <a:fontRef idx="minor">
+            <a:schemeClr val="lt1"/>
+          </a:fontRef>
+        </p:style>
+        <p:txBody>
+          <a:bodyPr rtlCol="0" anchor="ctr"/>
+          <a:lstStyle/>
+          <a:p>
+            <a:pPr algn="ctr"/>
+          </a:p>
+        </p:txBody>
+      </p:sp>
+      <p:sp>
+        <p:nvSpPr>
+          <p:cNvPr id="11" name="TextBox 10"/>
+          <p:cNvSpPr txBox="1"/>
+          <p:nvPr/>
+        </p:nvSpPr>
+        <p:spPr>
+          <a:xfrm>
+            <a:off x="777240" y="5440680"/>
+            <a:ext cx="3291840" cy="1143000"/>
+          </a:xfrm>
+          <a:prstGeom prst="rect">
+            <a:avLst/>
+          </a:prstGeom>
+          <a:noFill/>
+        </p:spPr>
+        <p:txBody>
+          <a:bodyPr wrap="square" lIns="0" rIns="0" tIns="0" bIns="0" anchor="t">
+            <a:spAutoFit/>
+          </a:bodyPr>
+          <a:lstStyle/>
+          <a:p>
+            <a:pPr algn="l">
+              <a:lnSpc>
+                <a:spcPct val="118000"/>
+              </a:lnSpc>
+            </a:pPr>
+            <a:r>
+              <a:rPr sz="2200" b="0" i="1">
+                <a:solidFill>
+                  <a:srgbClr val="1F3D88"/>
+                </a:solidFill>
+                <a:latin typeface="Cormorant Garamond"/>
+              </a:rPr>
+              <a:t>A laboratory, not a finished product.</a:t>
+            </a:r>
+          </a:p>
+        </p:txBody>
+      </p:sp>
+      <p:sp>
+        <p:nvSpPr>
+          <p:cNvPr id="12" name="TextBox 11"/>
+          <p:cNvSpPr txBox="1"/>
+          <p:nvPr/>
+        </p:nvSpPr>
+        <p:spPr>
+          <a:xfrm>
+            <a:off x="4526280" y="5440680"/>
+            <a:ext cx="6888175" cy="1143000"/>
+          </a:xfrm>
+          <a:prstGeom prst="rect">
+            <a:avLst/>
+          </a:prstGeom>
+          <a:noFill/>
+        </p:spPr>
+        <p:txBody>
+          <a:bodyPr wrap="square" lIns="0" rIns="0" tIns="0" bIns="0" anchor="t">
+            <a:spAutoFit/>
+          </a:bodyPr>
+          <a:lstStyle/>
+          <a:p>
+            <a:pPr algn="l">
+              <a:lnSpc>
+                <a:spcPct val="145000"/>
+              </a:lnSpc>
+            </a:pPr>
+            <a:r>
+              <a:rPr sz="1300" b="0" i="0">
                 <a:solidFill>
                   <a:srgbClr val="1C2638"/>
                 </a:solidFill>
@@ -3872,8 +4343,87 @@
         </p:nvSpPr>
         <p:spPr>
           <a:xfrm>
-            <a:off x="640080" y="502920"/>
-            <a:ext cx="10911535" cy="1371600"/>
+            <a:off x="777240" y="274320"/>
+            <a:ext cx="7315200" cy="320040"/>
+          </a:xfrm>
+          <a:prstGeom prst="rect">
+            <a:avLst/>
+          </a:prstGeom>
+          <a:noFill/>
+        </p:spPr>
+        <p:txBody>
+          <a:bodyPr wrap="square" lIns="0" rIns="0" tIns="0" bIns="0" anchor="ctr">
+            <a:spAutoFit/>
+          </a:bodyPr>
+          <a:lstStyle/>
+          <a:p>
+            <a:pPr algn="l"/>
+            <a:r>
+              <a:rPr sz="1100" b="1" i="0" spc="300">
+                <a:solidFill>
+                  <a:srgbClr val="0E1B36"/>
+                </a:solidFill>
+                <a:latin typeface="JetBrains Mono"/>
+              </a:rPr>
+              <a:t>SAN FRANCISCO · CIVIC ART MAP</a:t>
+            </a:r>
+          </a:p>
+        </p:txBody>
+      </p:sp>
+      <p:sp>
+        <p:nvSpPr>
+          <p:cNvPr id="3" name="Rectangle 2"/>
+          <p:cNvSpPr/>
+          <p:nvPr/>
+        </p:nvSpPr>
+        <p:spPr>
+          <a:xfrm>
+            <a:off x="0" y="749808"/>
+            <a:ext cx="12191695" cy="9525"/>
+          </a:xfrm>
+          <a:prstGeom prst="rect">
+            <a:avLst/>
+          </a:prstGeom>
+          <a:solidFill>
+            <a:srgbClr val="D6DEEA"/>
+          </a:solidFill>
+          <a:ln>
+            <a:noFill/>
+          </a:ln>
+          <a:effectLst/>
+        </p:spPr>
+        <p:style>
+          <a:lnRef idx="1">
+            <a:schemeClr val="accent1"/>
+          </a:lnRef>
+          <a:fillRef idx="3">
+            <a:schemeClr val="accent1"/>
+          </a:fillRef>
+          <a:effectRef idx="2">
+            <a:schemeClr val="accent1"/>
+          </a:effectRef>
+          <a:fontRef idx="minor">
+            <a:schemeClr val="lt1"/>
+          </a:fontRef>
+        </p:style>
+        <p:txBody>
+          <a:bodyPr rtlCol="0" anchor="ctr"/>
+          <a:lstStyle/>
+          <a:p>
+            <a:pPr algn="ctr"/>
+          </a:p>
+        </p:txBody>
+      </p:sp>
+      <p:sp>
+        <p:nvSpPr>
+          <p:cNvPr id="4" name="TextBox 3"/>
+          <p:cNvSpPr txBox="1"/>
+          <p:nvPr/>
+        </p:nvSpPr>
+        <p:spPr>
+          <a:xfrm>
+            <a:off x="777240" y="1097280"/>
+            <a:ext cx="10637215" cy="1645920"/>
           </a:xfrm>
           <a:prstGeom prst="rect">
             <a:avLst/>
@@ -3908,7 +4458,7 @@
               </a:spcAft>
             </a:pPr>
             <a:r>
-              <a:rPr sz="2400" b="0" i="0">
+              <a:rPr sz="3200" b="0" i="0">
                 <a:solidFill>
                   <a:srgbClr val="0E1B36"/>
                 </a:solidFill>
@@ -3921,14 +4471,14 @@
       </p:sp>
       <p:sp>
         <p:nvSpPr>
-          <p:cNvPr id="3" name="Rectangle 2"/>
+          <p:cNvPr id="5" name="Rectangle 4"/>
           <p:cNvSpPr/>
           <p:nvPr/>
         </p:nvSpPr>
         <p:spPr>
           <a:xfrm>
-            <a:off x="640080" y="2194560"/>
-            <a:ext cx="3454298" cy="31750"/>
+            <a:off x="777240" y="3154680"/>
+            <a:ext cx="3301898" cy="31750"/>
           </a:xfrm>
           <a:prstGeom prst="rect">
             <a:avLst/>
@@ -3965,14 +4515,14 @@
       </p:sp>
       <p:sp>
         <p:nvSpPr>
-          <p:cNvPr id="4" name="TextBox 3"/>
+          <p:cNvPr id="6" name="TextBox 5"/>
           <p:cNvSpPr txBox="1"/>
           <p:nvPr/>
         </p:nvSpPr>
         <p:spPr>
           <a:xfrm>
-            <a:off x="640080" y="2304288"/>
-            <a:ext cx="3454298" cy="4206240"/>
+            <a:off x="777240" y="3282696"/>
+            <a:ext cx="3301898" cy="3200400"/>
           </a:xfrm>
           <a:prstGeom prst="rect">
             <a:avLst/>
@@ -3986,28 +4536,62 @@
           <a:lstStyle/>
           <a:p>
             <a:pPr algn="l">
+              <a:lnSpc>
+                <a:spcPct val="115000"/>
+              </a:lnSpc>
+              <a:spcAft>
+                <a:spcPts val="1100"/>
+              </a:spcAft>
+            </a:pPr>
+            <a:r>
+              <a:rPr sz="2400" b="0" i="0">
+                <a:solidFill>
+                  <a:srgbClr val="0E1B36"/>
+                </a:solidFill>
+                <a:latin typeface="Cormorant Garamond"/>
+              </a:rPr>
+              <a:t>The cultural moment</a:t>
+            </a:r>
+          </a:p>
+          <a:p>
+            <a:pPr algn="l">
+              <a:lnSpc>
+                <a:spcPct val="142000"/>
+              </a:lnSpc>
               <a:spcAft>
                 <a:spcPts val="800"/>
               </a:spcAft>
             </a:pPr>
             <a:r>
-              <a:rPr sz="1800" b="0" i="0">
-                <a:solidFill>
-                  <a:srgbClr val="0E1B36"/>
-                </a:solidFill>
-                <a:latin typeface="Cormorant Garamond"/>
-              </a:rPr>
-              <a:t>The cultural moment</a:t>
+              <a:rPr sz="1200" b="1" i="0">
+                <a:solidFill>
+                  <a:srgbClr val="1F3D88"/>
+                </a:solidFill>
+                <a:latin typeface="Inter"/>
+              </a:rPr>
+              <a:t>•  </a:t>
+            </a:r>
+            <a:r>
+              <a:rPr sz="1200" b="0" i="0">
+                <a:solidFill>
+                  <a:srgbClr val="1C2638"/>
+                </a:solidFill>
+                <a:latin typeface="Inter"/>
+              </a:rPr>
+              <a:t>San Francisco's gallery and institutional ecosystem has been reshaped by a decade of rent pressure, the long tail of the pandemic, and the recent transitions at SFAI, ICA SF, and elsewhere.</a:t>
             </a:r>
           </a:p>
           <a:p>
             <a:pPr algn="l">
+              <a:lnSpc>
+                <a:spcPct val="142000"/>
+              </a:lnSpc>
               <a:spcAft>
-                <a:spcPts val="700"/>
+                <a:spcPts val="800"/>
               </a:spcAft>
             </a:pPr>
             <a:r>
-              <a:rPr sz="1100" b="1" i="0">
+              <a:rPr sz="1200" b="1" i="0">
                 <a:solidFill>
                   <a:srgbClr val="1F3D88"/>
                 </a:solidFill>
@@ -4016,23 +4600,26 @@
               <a:t>•  </a:t>
             </a:r>
             <a:r>
-              <a:rPr sz="1100" b="0" i="0">
+              <a:rPr sz="1200" b="0" i="0">
                 <a:solidFill>
                   <a:srgbClr val="1C2638"/>
                 </a:solidFill>
                 <a:latin typeface="Inter"/>
               </a:rPr>
-              <a:t>San Francisco's gallery and institutional ecosystem has been reshaped by a decade of rent pressure, the long tail of the pandemic, and the recent transitions at SFAI, ICA SF, and elsewhere.</a:t>
+              <a:t>The institutions that remain are working harder than ever to reach audiences while operating in relative isolation from one another.</a:t>
             </a:r>
           </a:p>
           <a:p>
             <a:pPr algn="l">
+              <a:lnSpc>
+                <a:spcPct val="142000"/>
+              </a:lnSpc>
               <a:spcAft>
-                <a:spcPts val="700"/>
+                <a:spcPts val="800"/>
               </a:spcAft>
             </a:pPr>
             <a:r>
-              <a:rPr sz="1100" b="1" i="0">
+              <a:rPr sz="1200" b="1" i="0">
                 <a:solidFill>
                   <a:srgbClr val="1F3D88"/>
                 </a:solidFill>
@@ -4041,37 +4628,12 @@
               <a:t>•  </a:t>
             </a:r>
             <a:r>
-              <a:rPr sz="1100" b="0" i="0">
+              <a:rPr sz="1200" b="0" i="0">
                 <a:solidFill>
                   <a:srgbClr val="1C2638"/>
                 </a:solidFill>
                 <a:latin typeface="Inter"/>
               </a:rPr>
-              <a:t>The institutions that remain are working harder than ever to reach audiences while operating in relative isolation from one another.</a:t>
-            </a:r>
-          </a:p>
-          <a:p>
-            <a:pPr algn="l">
-              <a:spcAft>
-                <a:spcPts val="700"/>
-              </a:spcAft>
-            </a:pPr>
-            <a:r>
-              <a:rPr sz="1100" b="1" i="0">
-                <a:solidFill>
-                  <a:srgbClr val="1F3D88"/>
-                </a:solidFill>
-                <a:latin typeface="Inter"/>
-              </a:rPr>
-              <a:t>•  </a:t>
-            </a:r>
-            <a:r>
-              <a:rPr sz="1100" b="0" i="0">
-                <a:solidFill>
-                  <a:srgbClr val="1C2638"/>
-                </a:solidFill>
-                <a:latin typeface="Inter"/>
-              </a:rPr>
               <a:t>The city's cultural map is fragmenting at exactly the moment when Mayor Lurie has made cultural revitalization a stated priority.</a:t>
             </a:r>
           </a:p>
@@ -4079,14 +4641,14 @@
       </p:sp>
       <p:sp>
         <p:nvSpPr>
-          <p:cNvPr id="5" name="Rectangle 4"/>
+          <p:cNvPr id="7" name="Rectangle 6"/>
           <p:cNvSpPr/>
           <p:nvPr/>
         </p:nvSpPr>
         <p:spPr>
           <a:xfrm>
-            <a:off x="4368698" y="2194560"/>
-            <a:ext cx="3454298" cy="31750"/>
+            <a:off x="4444898" y="3154680"/>
+            <a:ext cx="3301898" cy="31750"/>
           </a:xfrm>
           <a:prstGeom prst="rect">
             <a:avLst/>
@@ -4123,14 +4685,14 @@
       </p:sp>
       <p:sp>
         <p:nvSpPr>
-          <p:cNvPr id="6" name="TextBox 5"/>
+          <p:cNvPr id="8" name="TextBox 7"/>
           <p:cNvSpPr txBox="1"/>
           <p:nvPr/>
         </p:nvSpPr>
         <p:spPr>
           <a:xfrm>
-            <a:off x="4368698" y="2304288"/>
-            <a:ext cx="3454298" cy="4206240"/>
+            <a:off x="4444898" y="3282696"/>
+            <a:ext cx="3301898" cy="3200400"/>
           </a:xfrm>
           <a:prstGeom prst="rect">
             <a:avLst/>
@@ -4144,28 +4706,62 @@
           <a:lstStyle/>
           <a:p>
             <a:pPr algn="l">
+              <a:lnSpc>
+                <a:spcPct val="115000"/>
+              </a:lnSpc>
+              <a:spcAft>
+                <a:spcPts val="1100"/>
+              </a:spcAft>
+            </a:pPr>
+            <a:r>
+              <a:rPr sz="2400" b="0" i="0">
+                <a:solidFill>
+                  <a:srgbClr val="0E1B36"/>
+                </a:solidFill>
+                <a:latin typeface="Cormorant Garamond"/>
+              </a:rPr>
+              <a:t>The technology moment</a:t>
+            </a:r>
+          </a:p>
+          <a:p>
+            <a:pPr algn="l">
+              <a:lnSpc>
+                <a:spcPct val="142000"/>
+              </a:lnSpc>
               <a:spcAft>
                 <a:spcPts val="800"/>
               </a:spcAft>
             </a:pPr>
             <a:r>
-              <a:rPr sz="1800" b="0" i="0">
-                <a:solidFill>
-                  <a:srgbClr val="0E1B36"/>
-                </a:solidFill>
-                <a:latin typeface="Cormorant Garamond"/>
-              </a:rPr>
-              <a:t>The technology moment</a:t>
+              <a:rPr sz="1200" b="1" i="0">
+                <a:solidFill>
+                  <a:srgbClr val="1F3D88"/>
+                </a:solidFill>
+                <a:latin typeface="Inter"/>
+              </a:rPr>
+              <a:t>•  </a:t>
+            </a:r>
+            <a:r>
+              <a:rPr sz="1200" b="0" i="0">
+                <a:solidFill>
+                  <a:srgbClr val="1C2638"/>
+                </a:solidFill>
+                <a:latin typeface="Inter"/>
+              </a:rPr>
+              <a:t>For the first time, the technology to actually unlock the art experience exists. AI can read a wall label, a press release, an artist's Q&amp;A, and a curator's catalogue together—and offer the visitor a personalized way in.</a:t>
             </a:r>
           </a:p>
           <a:p>
             <a:pPr algn="l">
+              <a:lnSpc>
+                <a:spcPct val="142000"/>
+              </a:lnSpc>
               <a:spcAft>
-                <a:spcPts val="700"/>
+                <a:spcPts val="800"/>
               </a:spcAft>
             </a:pPr>
             <a:r>
-              <a:rPr sz="1100" b="1" i="0">
+              <a:rPr sz="1200" b="1" i="0">
                 <a:solidFill>
                   <a:srgbClr val="1F3D88"/>
                 </a:solidFill>
@@ -4174,23 +4770,26 @@
               <a:t>•  </a:t>
             </a:r>
             <a:r>
-              <a:rPr sz="1100" b="0" i="0">
+              <a:rPr sz="1200" b="0" i="0">
                 <a:solidFill>
                   <a:srgbClr val="1C2638"/>
                 </a:solidFill>
                 <a:latin typeface="Inter"/>
               </a:rPr>
-              <a:t>For the first time, the technology to actually unlock the art experience exists. AI can read a wall label, a press release, an artist's Q&amp;A, and a curator's catalogue together—and offer the visitor a personalized way in.</a:t>
+              <a:t>AR glasses and spatial-audio earbuds are about to make on-site interpretation effortless. Autonomous vehicles will reshape how visitors move through the city.</a:t>
             </a:r>
           </a:p>
           <a:p>
             <a:pPr algn="l">
+              <a:lnSpc>
+                <a:spcPct val="142000"/>
+              </a:lnSpc>
               <a:spcAft>
-                <a:spcPts val="700"/>
+                <a:spcPts val="800"/>
               </a:spcAft>
             </a:pPr>
             <a:r>
-              <a:rPr sz="1100" b="1" i="0">
+              <a:rPr sz="1200" b="1" i="0">
                 <a:solidFill>
                   <a:srgbClr val="1F3D88"/>
                 </a:solidFill>
@@ -4199,37 +4798,12 @@
               <a:t>•  </a:t>
             </a:r>
             <a:r>
-              <a:rPr sz="1100" b="0" i="0">
+              <a:rPr sz="1200" b="0" i="0">
                 <a:solidFill>
                   <a:srgbClr val="1C2638"/>
                 </a:solidFill>
                 <a:latin typeface="Inter"/>
               </a:rPr>
-              <a:t>AR glasses and spatial-audio earbuds are about to make on-site interpretation effortless. Autonomous vehicles will reshape how visitors move through the city.</a:t>
-            </a:r>
-          </a:p>
-          <a:p>
-            <a:pPr algn="l">
-              <a:spcAft>
-                <a:spcPts val="700"/>
-              </a:spcAft>
-            </a:pPr>
-            <a:r>
-              <a:rPr sz="1100" b="1" i="0">
-                <a:solidFill>
-                  <a:srgbClr val="1F3D88"/>
-                </a:solidFill>
-                <a:latin typeface="Inter"/>
-              </a:rPr>
-              <a:t>•  </a:t>
-            </a:r>
-            <a:r>
-              <a:rPr sz="1100" b="0" i="0">
-                <a:solidFill>
-                  <a:srgbClr val="1C2638"/>
-                </a:solidFill>
-                <a:latin typeface="Inter"/>
-              </a:rPr>
               <a:t>The next twenty-four months are when these capabilities go from emerging to ambient, and the city that builds the showcase first will set the template.</a:t>
             </a:r>
           </a:p>
@@ -4237,14 +4811,14 @@
       </p:sp>
       <p:sp>
         <p:nvSpPr>
-          <p:cNvPr id="7" name="Rectangle 6"/>
+          <p:cNvPr id="9" name="Rectangle 8"/>
           <p:cNvSpPr/>
           <p:nvPr/>
         </p:nvSpPr>
         <p:spPr>
           <a:xfrm>
-            <a:off x="8097316" y="2194560"/>
-            <a:ext cx="3454298" cy="31750"/>
+            <a:off x="8112556" y="3154680"/>
+            <a:ext cx="3301898" cy="31750"/>
           </a:xfrm>
           <a:prstGeom prst="rect">
             <a:avLst/>
@@ -4281,14 +4855,14 @@
       </p:sp>
       <p:sp>
         <p:nvSpPr>
-          <p:cNvPr id="8" name="TextBox 7"/>
+          <p:cNvPr id="10" name="TextBox 9"/>
           <p:cNvSpPr txBox="1"/>
           <p:nvPr/>
         </p:nvSpPr>
         <p:spPr>
           <a:xfrm>
-            <a:off x="8097316" y="2304288"/>
-            <a:ext cx="3454298" cy="4206240"/>
+            <a:off x="8112556" y="3282696"/>
+            <a:ext cx="3301898" cy="3200400"/>
           </a:xfrm>
           <a:prstGeom prst="rect">
             <a:avLst/>
@@ -4302,28 +4876,62 @@
           <a:lstStyle/>
           <a:p>
             <a:pPr algn="l">
+              <a:lnSpc>
+                <a:spcPct val="115000"/>
+              </a:lnSpc>
+              <a:spcAft>
+                <a:spcPts val="1100"/>
+              </a:spcAft>
+            </a:pPr>
+            <a:r>
+              <a:rPr sz="2400" b="0" i="0">
+                <a:solidFill>
+                  <a:srgbClr val="0E1B36"/>
+                </a:solidFill>
+                <a:latin typeface="Cormorant Garamond"/>
+              </a:rPr>
+              <a:t>The civic moment</a:t>
+            </a:r>
+          </a:p>
+          <a:p>
+            <a:pPr algn="l">
+              <a:lnSpc>
+                <a:spcPct val="142000"/>
+              </a:lnSpc>
               <a:spcAft>
                 <a:spcPts val="800"/>
               </a:spcAft>
             </a:pPr>
             <a:r>
-              <a:rPr sz="1800" b="0" i="0">
-                <a:solidFill>
-                  <a:srgbClr val="0E1B36"/>
-                </a:solidFill>
-                <a:latin typeface="Cormorant Garamond"/>
-              </a:rPr>
-              <a:t>The civic moment</a:t>
+              <a:rPr sz="1200" b="1" i="0">
+                <a:solidFill>
+                  <a:srgbClr val="1F3D88"/>
+                </a:solidFill>
+                <a:latin typeface="Inter"/>
+              </a:rPr>
+              <a:t>•  </a:t>
+            </a:r>
+            <a:r>
+              <a:rPr sz="1200" b="0" i="0">
+                <a:solidFill>
+                  <a:srgbClr val="1C2638"/>
+                </a:solidFill>
+                <a:latin typeface="Inter"/>
+              </a:rPr>
+              <a:t>San Francisco's tech leadership is under pressure to make the city a place worth living in—not just as philanthropy, but because the quality of civic life is foundational to attracting and keeping top talent.</a:t>
             </a:r>
           </a:p>
           <a:p>
             <a:pPr algn="l">
+              <a:lnSpc>
+                <a:spcPct val="142000"/>
+              </a:lnSpc>
               <a:spcAft>
-                <a:spcPts val="700"/>
+                <a:spcPts val="800"/>
               </a:spcAft>
             </a:pPr>
             <a:r>
-              <a:rPr sz="1100" b="1" i="0">
+              <a:rPr sz="1200" b="1" i="0">
                 <a:solidFill>
                   <a:srgbClr val="1F3D88"/>
                 </a:solidFill>
@@ -4332,23 +4940,26 @@
               <a:t>•  </a:t>
             </a:r>
             <a:r>
-              <a:rPr sz="1100" b="0" i="0">
+              <a:rPr sz="1200" b="0" i="0">
                 <a:solidFill>
                   <a:srgbClr val="1C2638"/>
                 </a:solidFill>
                 <a:latin typeface="Inter"/>
               </a:rPr>
-              <a:t>San Francisco's tech leadership is under pressure to make the city a place worth living in—not just as philanthropy, but because the quality of civic life is foundational to attracting and keeping top talent.</a:t>
+              <a:t>Voices like Patrick Collison's call for new aesthetics and Packy McCormick's appeal for modern magnificenza signal a hunger across the tech community for positive, generous expressions of the technological age.</a:t>
             </a:r>
           </a:p>
           <a:p>
             <a:pPr algn="l">
+              <a:lnSpc>
+                <a:spcPct val="142000"/>
+              </a:lnSpc>
               <a:spcAft>
-                <a:spcPts val="700"/>
+                <a:spcPts val="800"/>
               </a:spcAft>
             </a:pPr>
             <a:r>
-              <a:rPr sz="1100" b="1" i="0">
+              <a:rPr sz="1200" b="1" i="0">
                 <a:solidFill>
                   <a:srgbClr val="1F3D88"/>
                 </a:solidFill>
@@ -4357,32 +4968,7 @@
               <a:t>•  </a:t>
             </a:r>
             <a:r>
-              <a:rPr sz="1100" b="0" i="0">
-                <a:solidFill>
-                  <a:srgbClr val="1C2638"/>
-                </a:solidFill>
-                <a:latin typeface="Inter"/>
-              </a:rPr>
-              <a:t>Voices like Patrick Collison's call for new aesthetics and Packy McCormick's appeal for modern magnificenza signal a hunger across the tech community for positive, generous expressions of the technological age.</a:t>
-            </a:r>
-          </a:p>
-          <a:p>
-            <a:pPr algn="l">
-              <a:spcAft>
-                <a:spcPts val="700"/>
-              </a:spcAft>
-            </a:pPr>
-            <a:r>
-              <a:rPr sz="1100" b="1" i="0">
-                <a:solidFill>
-                  <a:srgbClr val="1F3D88"/>
-                </a:solidFill>
-                <a:latin typeface="Inter"/>
-              </a:rPr>
-              <a:t>•  </a:t>
-            </a:r>
-            <a:r>
-              <a:rPr sz="1100" b="0" i="0">
+              <a:rPr sz="1200" b="0" i="0">
                 <a:solidFill>
                   <a:srgbClr val="1C2638"/>
                 </a:solidFill>
@@ -4427,8 +5013,87 @@
         </p:nvSpPr>
         <p:spPr>
           <a:xfrm>
-            <a:off x="640080" y="502920"/>
-            <a:ext cx="10911535" cy="1463040"/>
+            <a:off x="777240" y="274320"/>
+            <a:ext cx="7315200" cy="320040"/>
+          </a:xfrm>
+          <a:prstGeom prst="rect">
+            <a:avLst/>
+          </a:prstGeom>
+          <a:noFill/>
+        </p:spPr>
+        <p:txBody>
+          <a:bodyPr wrap="square" lIns="0" rIns="0" tIns="0" bIns="0" anchor="ctr">
+            <a:spAutoFit/>
+          </a:bodyPr>
+          <a:lstStyle/>
+          <a:p>
+            <a:pPr algn="l"/>
+            <a:r>
+              <a:rPr sz="1100" b="1" i="0" spc="300">
+                <a:solidFill>
+                  <a:srgbClr val="0E1B36"/>
+                </a:solidFill>
+                <a:latin typeface="JetBrains Mono"/>
+              </a:rPr>
+              <a:t>SAN FRANCISCO · CIVIC ART MAP</a:t>
+            </a:r>
+          </a:p>
+        </p:txBody>
+      </p:sp>
+      <p:sp>
+        <p:nvSpPr>
+          <p:cNvPr id="3" name="Rectangle 2"/>
+          <p:cNvSpPr/>
+          <p:nvPr/>
+        </p:nvSpPr>
+        <p:spPr>
+          <a:xfrm>
+            <a:off x="0" y="749808"/>
+            <a:ext cx="12191695" cy="9525"/>
+          </a:xfrm>
+          <a:prstGeom prst="rect">
+            <a:avLst/>
+          </a:prstGeom>
+          <a:solidFill>
+            <a:srgbClr val="D6DEEA"/>
+          </a:solidFill>
+          <a:ln>
+            <a:noFill/>
+          </a:ln>
+          <a:effectLst/>
+        </p:spPr>
+        <p:style>
+          <a:lnRef idx="1">
+            <a:schemeClr val="accent1"/>
+          </a:lnRef>
+          <a:fillRef idx="3">
+            <a:schemeClr val="accent1"/>
+          </a:fillRef>
+          <a:effectRef idx="2">
+            <a:schemeClr val="accent1"/>
+          </a:effectRef>
+          <a:fontRef idx="minor">
+            <a:schemeClr val="lt1"/>
+          </a:fontRef>
+        </p:style>
+        <p:txBody>
+          <a:bodyPr rtlCol="0" anchor="ctr"/>
+          <a:lstStyle/>
+          <a:p>
+            <a:pPr algn="ctr"/>
+          </a:p>
+        </p:txBody>
+      </p:sp>
+      <p:sp>
+        <p:nvSpPr>
+          <p:cNvPr id="4" name="TextBox 3"/>
+          <p:cNvSpPr txBox="1"/>
+          <p:nvPr/>
+        </p:nvSpPr>
+        <p:spPr>
+          <a:xfrm>
+            <a:off x="777240" y="1097280"/>
+            <a:ext cx="10637215" cy="1645920"/>
           </a:xfrm>
           <a:prstGeom prst="rect">
             <a:avLst/>
@@ -4463,7 +5128,7 @@
               </a:spcAft>
             </a:pPr>
             <a:r>
-              <a:rPr sz="2200" b="0" i="0">
+              <a:rPr sz="3200" b="0" i="0">
                 <a:solidFill>
                   <a:srgbClr val="0E1B36"/>
                 </a:solidFill>
@@ -4476,14 +5141,14 @@
       </p:sp>
       <p:sp>
         <p:nvSpPr>
-          <p:cNvPr id="3" name="Rectangle 2"/>
+          <p:cNvPr id="5" name="Rectangle 4"/>
           <p:cNvSpPr/>
           <p:nvPr/>
         </p:nvSpPr>
         <p:spPr>
           <a:xfrm>
-            <a:off x="640080" y="2286000"/>
-            <a:ext cx="3503066" cy="2011680"/>
+            <a:off x="777240" y="3246120"/>
+            <a:ext cx="3411626" cy="1600200"/>
           </a:xfrm>
           <a:prstGeom prst="rect">
             <a:avLst/>
@@ -4522,14 +5187,14 @@
       </p:sp>
       <p:sp>
         <p:nvSpPr>
-          <p:cNvPr id="4" name="TextBox 3"/>
+          <p:cNvPr id="6" name="TextBox 5"/>
           <p:cNvSpPr txBox="1"/>
           <p:nvPr/>
         </p:nvSpPr>
         <p:spPr>
           <a:xfrm>
-            <a:off x="822960" y="2423160"/>
-            <a:ext cx="3137306" cy="1737360"/>
+            <a:off x="960120" y="3392424"/>
+            <a:ext cx="3045866" cy="1307592"/>
           </a:xfrm>
           <a:prstGeom prst="rect">
             <a:avLst/>
@@ -4559,12 +5224,15 @@
           </a:p>
           <a:p>
             <a:pPr algn="l">
+              <a:lnSpc>
+                <a:spcPct val="114000"/>
+              </a:lnSpc>
               <a:spcAft>
                 <a:spcPts val="600"/>
               </a:spcAft>
             </a:pPr>
             <a:r>
-              <a:rPr sz="1700" b="0" i="0">
+              <a:rPr sz="1900" b="0" i="0">
                 <a:solidFill>
                   <a:srgbClr val="0E1B36"/>
                 </a:solidFill>
@@ -4574,9 +5242,13 @@
             </a:r>
           </a:p>
           <a:p>
-            <a:pPr algn="l"/>
-            <a:r>
-              <a:rPr sz="1050" b="0" i="0">
+            <a:pPr algn="l">
+              <a:lnSpc>
+                <a:spcPct val="140000"/>
+              </a:lnSpc>
+            </a:pPr>
+            <a:r>
+              <a:rPr sz="1100" b="0" i="0">
                 <a:solidFill>
                   <a:srgbClr val="1C2638"/>
                 </a:solidFill>
@@ -4589,14 +5261,14 @@
       </p:sp>
       <p:sp>
         <p:nvSpPr>
-          <p:cNvPr id="5" name="Rectangle 4"/>
+          <p:cNvPr id="7" name="Rectangle 6"/>
           <p:cNvSpPr/>
           <p:nvPr/>
         </p:nvSpPr>
         <p:spPr>
           <a:xfrm>
-            <a:off x="4344314" y="2286000"/>
-            <a:ext cx="3503066" cy="2011680"/>
+            <a:off x="4390034" y="3246120"/>
+            <a:ext cx="3411626" cy="1600200"/>
           </a:xfrm>
           <a:prstGeom prst="rect">
             <a:avLst/>
@@ -4635,14 +5307,14 @@
       </p:sp>
       <p:sp>
         <p:nvSpPr>
-          <p:cNvPr id="6" name="TextBox 5"/>
+          <p:cNvPr id="8" name="TextBox 7"/>
           <p:cNvSpPr txBox="1"/>
           <p:nvPr/>
         </p:nvSpPr>
         <p:spPr>
           <a:xfrm>
-            <a:off x="4527194" y="2423160"/>
-            <a:ext cx="3137306" cy="1737360"/>
+            <a:off x="4572914" y="3392424"/>
+            <a:ext cx="3045866" cy="1307592"/>
           </a:xfrm>
           <a:prstGeom prst="rect">
             <a:avLst/>
@@ -4672,12 +5344,15 @@
           </a:p>
           <a:p>
             <a:pPr algn="l">
+              <a:lnSpc>
+                <a:spcPct val="114000"/>
+              </a:lnSpc>
               <a:spcAft>
                 <a:spcPts val="600"/>
               </a:spcAft>
             </a:pPr>
             <a:r>
-              <a:rPr sz="1700" b="0" i="0">
+              <a:rPr sz="1900" b="0" i="0">
                 <a:solidFill>
                   <a:srgbClr val="0E1B36"/>
                 </a:solidFill>
@@ -4687,9 +5362,13 @@
             </a:r>
           </a:p>
           <a:p>
-            <a:pPr algn="l"/>
-            <a:r>
-              <a:rPr sz="1050" b="0" i="0">
+            <a:pPr algn="l">
+              <a:lnSpc>
+                <a:spcPct val="140000"/>
+              </a:lnSpc>
+            </a:pPr>
+            <a:r>
+              <a:rPr sz="1100" b="0" i="0">
                 <a:solidFill>
                   <a:srgbClr val="1C2638"/>
                 </a:solidFill>
@@ -4702,14 +5381,14 @@
       </p:sp>
       <p:sp>
         <p:nvSpPr>
-          <p:cNvPr id="7" name="Rectangle 6"/>
+          <p:cNvPr id="9" name="Rectangle 8"/>
           <p:cNvSpPr/>
           <p:nvPr/>
         </p:nvSpPr>
         <p:spPr>
           <a:xfrm>
-            <a:off x="8048548" y="2286000"/>
-            <a:ext cx="3503066" cy="2011680"/>
+            <a:off x="8002828" y="3246120"/>
+            <a:ext cx="3411626" cy="1600200"/>
           </a:xfrm>
           <a:prstGeom prst="rect">
             <a:avLst/>
@@ -4748,14 +5427,14 @@
       </p:sp>
       <p:sp>
         <p:nvSpPr>
-          <p:cNvPr id="8" name="TextBox 7"/>
+          <p:cNvPr id="10" name="TextBox 9"/>
           <p:cNvSpPr txBox="1"/>
           <p:nvPr/>
         </p:nvSpPr>
         <p:spPr>
           <a:xfrm>
-            <a:off x="8231428" y="2423160"/>
-            <a:ext cx="3137306" cy="1737360"/>
+            <a:off x="8185708" y="3392424"/>
+            <a:ext cx="3045866" cy="1307592"/>
           </a:xfrm>
           <a:prstGeom prst="rect">
             <a:avLst/>
@@ -4785,12 +5464,15 @@
           </a:p>
           <a:p>
             <a:pPr algn="l">
+              <a:lnSpc>
+                <a:spcPct val="114000"/>
+              </a:lnSpc>
               <a:spcAft>
                 <a:spcPts val="600"/>
               </a:spcAft>
             </a:pPr>
             <a:r>
-              <a:rPr sz="1700" b="0" i="0">
+              <a:rPr sz="1900" b="0" i="0">
                 <a:solidFill>
                   <a:srgbClr val="0E1B36"/>
                 </a:solidFill>
@@ -4800,9 +5482,13 @@
             </a:r>
           </a:p>
           <a:p>
-            <a:pPr algn="l"/>
-            <a:r>
-              <a:rPr sz="1050" b="0" i="0">
+            <a:pPr algn="l">
+              <a:lnSpc>
+                <a:spcPct val="140000"/>
+              </a:lnSpc>
+            </a:pPr>
+            <a:r>
+              <a:rPr sz="1100" b="0" i="0">
                 <a:solidFill>
                   <a:srgbClr val="1C2638"/>
                 </a:solidFill>
@@ -4815,14 +5501,14 @@
       </p:sp>
       <p:sp>
         <p:nvSpPr>
-          <p:cNvPr id="9" name="Rectangle 8"/>
+          <p:cNvPr id="11" name="Rectangle 10"/>
           <p:cNvSpPr/>
           <p:nvPr/>
         </p:nvSpPr>
         <p:spPr>
           <a:xfrm>
-            <a:off x="640080" y="4498848"/>
-            <a:ext cx="3503066" cy="2011680"/>
+            <a:off x="777240" y="5047488"/>
+            <a:ext cx="3411626" cy="1600200"/>
           </a:xfrm>
           <a:prstGeom prst="rect">
             <a:avLst/>
@@ -4861,14 +5547,14 @@
       </p:sp>
       <p:sp>
         <p:nvSpPr>
-          <p:cNvPr id="10" name="TextBox 9"/>
+          <p:cNvPr id="12" name="TextBox 11"/>
           <p:cNvSpPr txBox="1"/>
           <p:nvPr/>
         </p:nvSpPr>
         <p:spPr>
           <a:xfrm>
-            <a:off x="822960" y="4636008"/>
-            <a:ext cx="3137306" cy="1737360"/>
+            <a:off x="960120" y="5193792"/>
+            <a:ext cx="3045866" cy="1307592"/>
           </a:xfrm>
           <a:prstGeom prst="rect">
             <a:avLst/>
@@ -4898,12 +5584,15 @@
           </a:p>
           <a:p>
             <a:pPr algn="l">
+              <a:lnSpc>
+                <a:spcPct val="114000"/>
+              </a:lnSpc>
               <a:spcAft>
                 <a:spcPts val="600"/>
               </a:spcAft>
             </a:pPr>
             <a:r>
-              <a:rPr sz="1700" b="0" i="0">
+              <a:rPr sz="1900" b="0" i="0">
                 <a:solidFill>
                   <a:srgbClr val="0E1B36"/>
                 </a:solidFill>
@@ -4913,9 +5602,13 @@
             </a:r>
           </a:p>
           <a:p>
-            <a:pPr algn="l"/>
-            <a:r>
-              <a:rPr sz="1050" b="0" i="0">
+            <a:pPr algn="l">
+              <a:lnSpc>
+                <a:spcPct val="140000"/>
+              </a:lnSpc>
+            </a:pPr>
+            <a:r>
+              <a:rPr sz="1100" b="0" i="0">
                 <a:solidFill>
                   <a:srgbClr val="1C2638"/>
                 </a:solidFill>
@@ -4928,14 +5621,14 @@
       </p:sp>
       <p:sp>
         <p:nvSpPr>
-          <p:cNvPr id="11" name="Rectangle 10"/>
+          <p:cNvPr id="13" name="Rectangle 12"/>
           <p:cNvSpPr/>
           <p:nvPr/>
         </p:nvSpPr>
         <p:spPr>
           <a:xfrm>
-            <a:off x="4344314" y="4498848"/>
-            <a:ext cx="3503066" cy="2011680"/>
+            <a:off x="4390034" y="5047488"/>
+            <a:ext cx="3411626" cy="1600200"/>
           </a:xfrm>
           <a:prstGeom prst="rect">
             <a:avLst/>
@@ -4974,14 +5667,14 @@
       </p:sp>
       <p:sp>
         <p:nvSpPr>
-          <p:cNvPr id="12" name="TextBox 11"/>
+          <p:cNvPr id="14" name="TextBox 13"/>
           <p:cNvSpPr txBox="1"/>
           <p:nvPr/>
         </p:nvSpPr>
         <p:spPr>
           <a:xfrm>
-            <a:off x="4527194" y="4636008"/>
-            <a:ext cx="3137306" cy="1737360"/>
+            <a:off x="4572914" y="5193792"/>
+            <a:ext cx="3045866" cy="1307592"/>
           </a:xfrm>
           <a:prstGeom prst="rect">
             <a:avLst/>
@@ -5011,12 +5704,15 @@
           </a:p>
           <a:p>
             <a:pPr algn="l">
+              <a:lnSpc>
+                <a:spcPct val="114000"/>
+              </a:lnSpc>
               <a:spcAft>
                 <a:spcPts val="600"/>
               </a:spcAft>
             </a:pPr>
             <a:r>
-              <a:rPr sz="1700" b="0" i="0">
+              <a:rPr sz="1900" b="0" i="0">
                 <a:solidFill>
                   <a:srgbClr val="0E1B36"/>
                 </a:solidFill>
@@ -5026,9 +5722,13 @@
             </a:r>
           </a:p>
           <a:p>
-            <a:pPr algn="l"/>
-            <a:r>
-              <a:rPr sz="1050" b="0" i="0">
+            <a:pPr algn="l">
+              <a:lnSpc>
+                <a:spcPct val="140000"/>
+              </a:lnSpc>
+            </a:pPr>
+            <a:r>
+              <a:rPr sz="1100" b="0" i="0">
                 <a:solidFill>
                   <a:srgbClr val="1C2638"/>
                 </a:solidFill>
@@ -5041,14 +5741,14 @@
       </p:sp>
       <p:sp>
         <p:nvSpPr>
-          <p:cNvPr id="13" name="Rectangle 12"/>
+          <p:cNvPr id="15" name="Rectangle 14"/>
           <p:cNvSpPr/>
           <p:nvPr/>
         </p:nvSpPr>
         <p:spPr>
           <a:xfrm>
-            <a:off x="8048548" y="4498848"/>
-            <a:ext cx="3503066" cy="2011680"/>
+            <a:off x="8002828" y="5047488"/>
+            <a:ext cx="3411626" cy="1600200"/>
           </a:xfrm>
           <a:prstGeom prst="rect">
             <a:avLst/>
@@ -5087,14 +5787,14 @@
       </p:sp>
       <p:sp>
         <p:nvSpPr>
-          <p:cNvPr id="14" name="TextBox 13"/>
+          <p:cNvPr id="16" name="TextBox 15"/>
           <p:cNvSpPr txBox="1"/>
           <p:nvPr/>
         </p:nvSpPr>
         <p:spPr>
           <a:xfrm>
-            <a:off x="8231428" y="4636008"/>
-            <a:ext cx="3137306" cy="1737360"/>
+            <a:off x="8185708" y="5193792"/>
+            <a:ext cx="3045866" cy="1307592"/>
           </a:xfrm>
           <a:prstGeom prst="rect">
             <a:avLst/>
@@ -5124,12 +5824,15 @@
           </a:p>
           <a:p>
             <a:pPr algn="l">
+              <a:lnSpc>
+                <a:spcPct val="114000"/>
+              </a:lnSpc>
               <a:spcAft>
                 <a:spcPts val="600"/>
               </a:spcAft>
             </a:pPr>
             <a:r>
-              <a:rPr sz="1700" b="0" i="0">
+              <a:rPr sz="1900" b="0" i="0">
                 <a:solidFill>
                   <a:srgbClr val="0E1B36"/>
                 </a:solidFill>
@@ -5139,9 +5842,13 @@
             </a:r>
           </a:p>
           <a:p>
-            <a:pPr algn="l"/>
-            <a:r>
-              <a:rPr sz="1050" b="0" i="0">
+            <a:pPr algn="l">
+              <a:lnSpc>
+                <a:spcPct val="140000"/>
+              </a:lnSpc>
+            </a:pPr>
+            <a:r>
+              <a:rPr sz="1100" b="0" i="0">
                 <a:solidFill>
                   <a:srgbClr val="1C2638"/>
                 </a:solidFill>
@@ -5186,8 +5893,87 @@
         </p:nvSpPr>
         <p:spPr>
           <a:xfrm>
-            <a:off x="640080" y="502920"/>
-            <a:ext cx="10911535" cy="1828800"/>
+            <a:off x="777240" y="274320"/>
+            <a:ext cx="7315200" cy="320040"/>
+          </a:xfrm>
+          <a:prstGeom prst="rect">
+            <a:avLst/>
+          </a:prstGeom>
+          <a:noFill/>
+        </p:spPr>
+        <p:txBody>
+          <a:bodyPr wrap="square" lIns="0" rIns="0" tIns="0" bIns="0" anchor="ctr">
+            <a:spAutoFit/>
+          </a:bodyPr>
+          <a:lstStyle/>
+          <a:p>
+            <a:pPr algn="l"/>
+            <a:r>
+              <a:rPr sz="1100" b="1" i="0" spc="300">
+                <a:solidFill>
+                  <a:srgbClr val="0E1B36"/>
+                </a:solidFill>
+                <a:latin typeface="JetBrains Mono"/>
+              </a:rPr>
+              <a:t>SAN FRANCISCO · CIVIC ART MAP</a:t>
+            </a:r>
+          </a:p>
+        </p:txBody>
+      </p:sp>
+      <p:sp>
+        <p:nvSpPr>
+          <p:cNvPr id="3" name="Rectangle 2"/>
+          <p:cNvSpPr/>
+          <p:nvPr/>
+        </p:nvSpPr>
+        <p:spPr>
+          <a:xfrm>
+            <a:off x="0" y="749808"/>
+            <a:ext cx="12191695" cy="9525"/>
+          </a:xfrm>
+          <a:prstGeom prst="rect">
+            <a:avLst/>
+          </a:prstGeom>
+          <a:solidFill>
+            <a:srgbClr val="D6DEEA"/>
+          </a:solidFill>
+          <a:ln>
+            <a:noFill/>
+          </a:ln>
+          <a:effectLst/>
+        </p:spPr>
+        <p:style>
+          <a:lnRef idx="1">
+            <a:schemeClr val="accent1"/>
+          </a:lnRef>
+          <a:fillRef idx="3">
+            <a:schemeClr val="accent1"/>
+          </a:fillRef>
+          <a:effectRef idx="2">
+            <a:schemeClr val="accent1"/>
+          </a:effectRef>
+          <a:fontRef idx="minor">
+            <a:schemeClr val="lt1"/>
+          </a:fontRef>
+        </p:style>
+        <p:txBody>
+          <a:bodyPr rtlCol="0" anchor="ctr"/>
+          <a:lstStyle/>
+          <a:p>
+            <a:pPr algn="ctr"/>
+          </a:p>
+        </p:txBody>
+      </p:sp>
+      <p:sp>
+        <p:nvSpPr>
+          <p:cNvPr id="4" name="TextBox 3"/>
+          <p:cNvSpPr txBox="1"/>
+          <p:nvPr/>
+        </p:nvSpPr>
+        <p:spPr>
+          <a:xfrm>
+            <a:off x="777240" y="1097280"/>
+            <a:ext cx="10637215" cy="2103120"/>
           </a:xfrm>
           <a:prstGeom prst="rect">
             <a:avLst/>
@@ -5222,7 +6008,7 @@
               </a:spcAft>
             </a:pPr>
             <a:r>
-              <a:rPr sz="2400" b="0" i="0">
+              <a:rPr sz="3200" b="0" i="0">
                 <a:solidFill>
                   <a:srgbClr val="0E1B36"/>
                 </a:solidFill>
@@ -5233,12 +6019,15 @@
           </a:p>
           <a:p>
             <a:pPr algn="l">
-              <a:spcAft>
-                <a:spcPts val="1400"/>
-              </a:spcAft>
+              <a:lnSpc>
+                <a:spcPct val="142000"/>
+              </a:lnSpc>
+              <a:spcBef>
+                <a:spcPts val="400"/>
+              </a:spcBef>
             </a:pPr>
             <a:r>
-              <a:rPr sz="1200" b="0" i="0">
+              <a:rPr sz="1400" b="0" i="0">
                 <a:solidFill>
                   <a:srgbClr val="1C2638"/>
                 </a:solidFill>
@@ -5251,14 +6040,14 @@
       </p:sp>
       <p:sp>
         <p:nvSpPr>
-          <p:cNvPr id="3" name="TextBox 2"/>
+          <p:cNvPr id="5" name="TextBox 4"/>
           <p:cNvSpPr txBox="1"/>
           <p:nvPr/>
         </p:nvSpPr>
         <p:spPr>
           <a:xfrm>
-            <a:off x="640080" y="4023360"/>
-            <a:ext cx="3454298" cy="1828800"/>
+            <a:off x="777240" y="3703320"/>
+            <a:ext cx="3301898" cy="1645920"/>
           </a:xfrm>
           <a:prstGeom prst="rect">
             <a:avLst/>
@@ -5277,7 +6066,7 @@
               </a:spcAft>
             </a:pPr>
             <a:r>
-              <a:rPr sz="1200" b="1" i="0">
+              <a:rPr sz="1300" b="1" i="0">
                 <a:solidFill>
                   <a:srgbClr val="1F3D88"/>
                 </a:solidFill>
@@ -5288,12 +6077,15 @@
           </a:p>
           <a:p>
             <a:pPr algn="l">
+              <a:lnSpc>
+                <a:spcPct val="114000"/>
+              </a:lnSpc>
               <a:spcAft>
                 <a:spcPts val="600"/>
               </a:spcAft>
             </a:pPr>
             <a:r>
-              <a:rPr sz="2200" b="0" i="0">
+              <a:rPr sz="2600" b="0" i="0">
                 <a:solidFill>
                   <a:srgbClr val="0E1B36"/>
                 </a:solidFill>
@@ -5303,9 +6095,13 @@
             </a:r>
           </a:p>
           <a:p>
-            <a:pPr algn="l"/>
-            <a:r>
-              <a:rPr sz="1050" b="0" i="0">
+            <a:pPr algn="l">
+              <a:lnSpc>
+                <a:spcPct val="142000"/>
+              </a:lnSpc>
+            </a:pPr>
+            <a:r>
+              <a:rPr sz="1150" b="0" i="0">
                 <a:solidFill>
                   <a:srgbClr val="1C2638"/>
                 </a:solidFill>
@@ -5318,14 +6114,14 @@
       </p:sp>
       <p:sp>
         <p:nvSpPr>
-          <p:cNvPr id="4" name="TextBox 3"/>
+          <p:cNvPr id="6" name="TextBox 5"/>
           <p:cNvSpPr txBox="1"/>
           <p:nvPr/>
         </p:nvSpPr>
         <p:spPr>
           <a:xfrm>
-            <a:off x="4368698" y="4023360"/>
-            <a:ext cx="3454298" cy="1828800"/>
+            <a:off x="4444898" y="3703320"/>
+            <a:ext cx="3301898" cy="1645920"/>
           </a:xfrm>
           <a:prstGeom prst="rect">
             <a:avLst/>
@@ -5344,7 +6140,7 @@
               </a:spcAft>
             </a:pPr>
             <a:r>
-              <a:rPr sz="1200" b="1" i="0">
+              <a:rPr sz="1300" b="1" i="0">
                 <a:solidFill>
                   <a:srgbClr val="1F3D88"/>
                 </a:solidFill>
@@ -5355,12 +6151,15 @@
           </a:p>
           <a:p>
             <a:pPr algn="l">
+              <a:lnSpc>
+                <a:spcPct val="114000"/>
+              </a:lnSpc>
               <a:spcAft>
                 <a:spcPts val="600"/>
               </a:spcAft>
             </a:pPr>
             <a:r>
-              <a:rPr sz="2200" b="0" i="0">
+              <a:rPr sz="2600" b="0" i="0">
                 <a:solidFill>
                   <a:srgbClr val="0E1B36"/>
                 </a:solidFill>
@@ -5370,9 +6169,13 @@
             </a:r>
           </a:p>
           <a:p>
-            <a:pPr algn="l"/>
-            <a:r>
-              <a:rPr sz="1050" b="0" i="0">
+            <a:pPr algn="l">
+              <a:lnSpc>
+                <a:spcPct val="142000"/>
+              </a:lnSpc>
+            </a:pPr>
+            <a:r>
+              <a:rPr sz="1150" b="0" i="0">
                 <a:solidFill>
                   <a:srgbClr val="1C2638"/>
                 </a:solidFill>
@@ -5385,14 +6188,14 @@
       </p:sp>
       <p:sp>
         <p:nvSpPr>
-          <p:cNvPr id="5" name="TextBox 4"/>
+          <p:cNvPr id="7" name="TextBox 6"/>
           <p:cNvSpPr txBox="1"/>
           <p:nvPr/>
         </p:nvSpPr>
         <p:spPr>
           <a:xfrm>
-            <a:off x="8097316" y="4023360"/>
-            <a:ext cx="3454298" cy="1828800"/>
+            <a:off x="8112556" y="3703320"/>
+            <a:ext cx="3301898" cy="1645920"/>
           </a:xfrm>
           <a:prstGeom prst="rect">
             <a:avLst/>
@@ -5411,7 +6214,7 @@
               </a:spcAft>
             </a:pPr>
             <a:r>
-              <a:rPr sz="1200" b="1" i="0">
+              <a:rPr sz="1300" b="1" i="0">
                 <a:solidFill>
                   <a:srgbClr val="1F3D88"/>
                 </a:solidFill>
@@ -5422,12 +6225,15 @@
           </a:p>
           <a:p>
             <a:pPr algn="l">
+              <a:lnSpc>
+                <a:spcPct val="114000"/>
+              </a:lnSpc>
               <a:spcAft>
                 <a:spcPts val="600"/>
               </a:spcAft>
             </a:pPr>
             <a:r>
-              <a:rPr sz="2200" b="0" i="0">
+              <a:rPr sz="2600" b="0" i="0">
                 <a:solidFill>
                   <a:srgbClr val="0E1B36"/>
                 </a:solidFill>
@@ -5437,9 +6243,13 @@
             </a:r>
           </a:p>
           <a:p>
-            <a:pPr algn="l"/>
-            <a:r>
-              <a:rPr sz="1050" b="0" i="0">
+            <a:pPr algn="l">
+              <a:lnSpc>
+                <a:spcPct val="142000"/>
+              </a:lnSpc>
+            </a:pPr>
+            <a:r>
+              <a:rPr sz="1150" b="0" i="0">
                 <a:solidFill>
                   <a:srgbClr val="1C2638"/>
                 </a:solidFill>
@@ -5452,13 +6262,13 @@
       </p:sp>
       <p:sp>
         <p:nvSpPr>
-          <p:cNvPr id="6" name="Rounded Rectangle 5"/>
+          <p:cNvPr id="8" name="Rounded Rectangle 7"/>
           <p:cNvSpPr/>
           <p:nvPr/>
         </p:nvSpPr>
         <p:spPr>
           <a:xfrm>
-            <a:off x="4174337" y="6126480"/>
+            <a:off x="4174337" y="5577840"/>
             <a:ext cx="492760" cy="274320"/>
           </a:xfrm>
           <a:prstGeom prst="roundRect">
@@ -5509,13 +6319,13 @@
       </p:sp>
       <p:sp>
         <p:nvSpPr>
-          <p:cNvPr id="7" name="Rounded Rectangle 6"/>
+          <p:cNvPr id="9" name="Rounded Rectangle 8"/>
           <p:cNvSpPr/>
           <p:nvPr/>
         </p:nvSpPr>
         <p:spPr>
           <a:xfrm>
-            <a:off x="4758537" y="6126480"/>
+            <a:off x="4758537" y="5577840"/>
             <a:ext cx="782320" cy="274320"/>
           </a:xfrm>
           <a:prstGeom prst="roundRect">
@@ -5566,13 +6376,13 @@
       </p:sp>
       <p:sp>
         <p:nvSpPr>
-          <p:cNvPr id="8" name="Rounded Rectangle 7"/>
+          <p:cNvPr id="10" name="Rounded Rectangle 9"/>
           <p:cNvSpPr/>
           <p:nvPr/>
         </p:nvSpPr>
         <p:spPr>
           <a:xfrm>
-            <a:off x="5632297" y="6126480"/>
+            <a:off x="5632297" y="5577840"/>
             <a:ext cx="492760" cy="274320"/>
           </a:xfrm>
           <a:prstGeom prst="roundRect">
@@ -5623,13 +6433,13 @@
       </p:sp>
       <p:sp>
         <p:nvSpPr>
-          <p:cNvPr id="9" name="Rounded Rectangle 8"/>
+          <p:cNvPr id="11" name="Rounded Rectangle 10"/>
           <p:cNvSpPr/>
           <p:nvPr/>
         </p:nvSpPr>
         <p:spPr>
           <a:xfrm>
-            <a:off x="6216497" y="6126480"/>
+            <a:off x="6216497" y="5577840"/>
             <a:ext cx="999490" cy="274320"/>
           </a:xfrm>
           <a:prstGeom prst="roundRect">
@@ -5680,13 +6490,13 @@
       </p:sp>
       <p:sp>
         <p:nvSpPr>
-          <p:cNvPr id="10" name="Rounded Rectangle 9"/>
+          <p:cNvPr id="12" name="Rounded Rectangle 11"/>
           <p:cNvSpPr/>
           <p:nvPr/>
         </p:nvSpPr>
         <p:spPr>
           <a:xfrm>
-            <a:off x="7307427" y="6126480"/>
+            <a:off x="7307427" y="5577840"/>
             <a:ext cx="709930" cy="274320"/>
           </a:xfrm>
           <a:prstGeom prst="roundRect">
@@ -5737,14 +6547,14 @@
       </p:sp>
       <p:sp>
         <p:nvSpPr>
-          <p:cNvPr id="11" name="TextBox 10"/>
+          <p:cNvPr id="13" name="TextBox 12"/>
           <p:cNvSpPr txBox="1"/>
           <p:nvPr/>
         </p:nvSpPr>
         <p:spPr>
           <a:xfrm>
-            <a:off x="640080" y="6510528"/>
-            <a:ext cx="10911535" cy="274320"/>
+            <a:off x="777240" y="5961888"/>
+            <a:ext cx="10637215" cy="274320"/>
           </a:xfrm>
           <a:prstGeom prst="rect">
             <a:avLst/>
@@ -5804,8 +6614,87 @@
         </p:nvSpPr>
         <p:spPr>
           <a:xfrm>
-            <a:off x="640080" y="502920"/>
-            <a:ext cx="10911535" cy="2011680"/>
+            <a:off x="777240" y="274320"/>
+            <a:ext cx="7315200" cy="320040"/>
+          </a:xfrm>
+          <a:prstGeom prst="rect">
+            <a:avLst/>
+          </a:prstGeom>
+          <a:noFill/>
+        </p:spPr>
+        <p:txBody>
+          <a:bodyPr wrap="square" lIns="0" rIns="0" tIns="0" bIns="0" anchor="ctr">
+            <a:spAutoFit/>
+          </a:bodyPr>
+          <a:lstStyle/>
+          <a:p>
+            <a:pPr algn="l"/>
+            <a:r>
+              <a:rPr sz="1100" b="1" i="0" spc="300">
+                <a:solidFill>
+                  <a:srgbClr val="0E1B36"/>
+                </a:solidFill>
+                <a:latin typeface="JetBrains Mono"/>
+              </a:rPr>
+              <a:t>SAN FRANCISCO · CIVIC ART MAP</a:t>
+            </a:r>
+          </a:p>
+        </p:txBody>
+      </p:sp>
+      <p:sp>
+        <p:nvSpPr>
+          <p:cNvPr id="3" name="Rectangle 2"/>
+          <p:cNvSpPr/>
+          <p:nvPr/>
+        </p:nvSpPr>
+        <p:spPr>
+          <a:xfrm>
+            <a:off x="0" y="749808"/>
+            <a:ext cx="12191695" cy="9525"/>
+          </a:xfrm>
+          <a:prstGeom prst="rect">
+            <a:avLst/>
+          </a:prstGeom>
+          <a:solidFill>
+            <a:srgbClr val="D6DEEA"/>
+          </a:solidFill>
+          <a:ln>
+            <a:noFill/>
+          </a:ln>
+          <a:effectLst/>
+        </p:spPr>
+        <p:style>
+          <a:lnRef idx="1">
+            <a:schemeClr val="accent1"/>
+          </a:lnRef>
+          <a:fillRef idx="3">
+            <a:schemeClr val="accent1"/>
+          </a:fillRef>
+          <a:effectRef idx="2">
+            <a:schemeClr val="accent1"/>
+          </a:effectRef>
+          <a:fontRef idx="minor">
+            <a:schemeClr val="lt1"/>
+          </a:fontRef>
+        </p:style>
+        <p:txBody>
+          <a:bodyPr rtlCol="0" anchor="ctr"/>
+          <a:lstStyle/>
+          <a:p>
+            <a:pPr algn="ctr"/>
+          </a:p>
+        </p:txBody>
+      </p:sp>
+      <p:sp>
+        <p:nvSpPr>
+          <p:cNvPr id="4" name="TextBox 3"/>
+          <p:cNvSpPr txBox="1"/>
+          <p:nvPr/>
+        </p:nvSpPr>
+        <p:spPr>
+          <a:xfrm>
+            <a:off x="777240" y="1097280"/>
+            <a:ext cx="10637215" cy="2286000"/>
           </a:xfrm>
           <a:prstGeom prst="rect">
             <a:avLst/>
@@ -5840,7 +6729,7 @@
               </a:spcAft>
             </a:pPr>
             <a:r>
-              <a:rPr sz="2200" b="0" i="0">
+              <a:rPr sz="3200" b="0" i="0">
                 <a:solidFill>
                   <a:srgbClr val="0E1B36"/>
                 </a:solidFill>
@@ -5851,12 +6740,15 @@
           </a:p>
           <a:p>
             <a:pPr algn="l">
-              <a:spcAft>
-                <a:spcPts val="1200"/>
-              </a:spcAft>
+              <a:lnSpc>
+                <a:spcPct val="142000"/>
+              </a:lnSpc>
+              <a:spcBef>
+                <a:spcPts val="400"/>
+              </a:spcBef>
             </a:pPr>
             <a:r>
-              <a:rPr sz="1200" b="0" i="0">
+              <a:rPr sz="1300" b="0" i="0">
                 <a:solidFill>
                   <a:srgbClr val="1C2638"/>
                 </a:solidFill>
@@ -5869,14 +6761,14 @@
       </p:sp>
       <p:sp>
         <p:nvSpPr>
-          <p:cNvPr id="3" name="Rectangle 2"/>
+          <p:cNvPr id="5" name="Rectangle 4"/>
           <p:cNvSpPr/>
           <p:nvPr/>
         </p:nvSpPr>
         <p:spPr>
           <a:xfrm>
-            <a:off x="640080" y="3840480"/>
-            <a:ext cx="3515258" cy="1783080"/>
+            <a:off x="777240" y="4251960"/>
+            <a:ext cx="3393338" cy="1417320"/>
           </a:xfrm>
           <a:prstGeom prst="rect">
             <a:avLst/>
@@ -5913,14 +6805,14 @@
       </p:sp>
       <p:sp>
         <p:nvSpPr>
-          <p:cNvPr id="4" name="Rectangle 3"/>
+          <p:cNvPr id="6" name="Rectangle 5"/>
           <p:cNvSpPr/>
           <p:nvPr/>
         </p:nvSpPr>
         <p:spPr>
           <a:xfrm>
-            <a:off x="640080" y="3840480"/>
-            <a:ext cx="3515258" cy="38100"/>
+            <a:off x="777240" y="4251960"/>
+            <a:ext cx="3393338" cy="38100"/>
           </a:xfrm>
           <a:prstGeom prst="rect">
             <a:avLst/>
@@ -5957,14 +6849,14 @@
       </p:sp>
       <p:sp>
         <p:nvSpPr>
-          <p:cNvPr id="5" name="TextBox 4"/>
+          <p:cNvPr id="7" name="TextBox 6"/>
           <p:cNvSpPr txBox="1"/>
           <p:nvPr/>
         </p:nvSpPr>
         <p:spPr>
           <a:xfrm>
-            <a:off x="804672" y="3968496"/>
-            <a:ext cx="3186074" cy="1554480"/>
+            <a:off x="941832" y="4379976"/>
+            <a:ext cx="3064154" cy="1161288"/>
           </a:xfrm>
           <a:prstGeom prst="rect">
             <a:avLst/>
@@ -5978,12 +6870,15 @@
           <a:lstStyle/>
           <a:p>
             <a:pPr algn="l">
+              <a:lnSpc>
+                <a:spcPct val="118000"/>
+              </a:lnSpc>
               <a:spcAft>
                 <a:spcPts val="600"/>
               </a:spcAft>
             </a:pPr>
             <a:r>
-              <a:rPr sz="1700" b="0" i="0">
+              <a:rPr sz="2000" b="0" i="0">
                 <a:solidFill>
                   <a:srgbClr val="0E1B36"/>
                 </a:solidFill>
@@ -5993,9 +6888,13 @@
             </a:r>
           </a:p>
           <a:p>
-            <a:pPr algn="l"/>
-            <a:r>
-              <a:rPr sz="1000" b="0" i="0">
+            <a:pPr algn="l">
+              <a:lnSpc>
+                <a:spcPct val="140000"/>
+              </a:lnSpc>
+            </a:pPr>
+            <a:r>
+              <a:rPr sz="1100" b="0" i="0">
                 <a:solidFill>
                   <a:srgbClr val="1C2638"/>
                 </a:solidFill>
@@ -6008,14 +6907,14 @@
       </p:sp>
       <p:sp>
         <p:nvSpPr>
-          <p:cNvPr id="6" name="Rectangle 5"/>
+          <p:cNvPr id="8" name="Rectangle 7"/>
           <p:cNvSpPr/>
           <p:nvPr/>
         </p:nvSpPr>
         <p:spPr>
           <a:xfrm>
-            <a:off x="4338218" y="3840480"/>
-            <a:ext cx="3515258" cy="1783080"/>
+            <a:off x="4399178" y="4251960"/>
+            <a:ext cx="3393338" cy="1417320"/>
           </a:xfrm>
           <a:prstGeom prst="rect">
             <a:avLst/>
@@ -6052,14 +6951,14 @@
       </p:sp>
       <p:sp>
         <p:nvSpPr>
-          <p:cNvPr id="7" name="Rectangle 6"/>
+          <p:cNvPr id="9" name="Rectangle 8"/>
           <p:cNvSpPr/>
           <p:nvPr/>
         </p:nvSpPr>
         <p:spPr>
           <a:xfrm>
-            <a:off x="4338218" y="3840480"/>
-            <a:ext cx="3515258" cy="38100"/>
+            <a:off x="4399178" y="4251960"/>
+            <a:ext cx="3393338" cy="38100"/>
           </a:xfrm>
           <a:prstGeom prst="rect">
             <a:avLst/>
@@ -6096,14 +6995,14 @@
       </p:sp>
       <p:sp>
         <p:nvSpPr>
-          <p:cNvPr id="8" name="TextBox 7"/>
+          <p:cNvPr id="10" name="TextBox 9"/>
           <p:cNvSpPr txBox="1"/>
           <p:nvPr/>
         </p:nvSpPr>
         <p:spPr>
           <a:xfrm>
-            <a:off x="4502810" y="3968496"/>
-            <a:ext cx="3186074" cy="1554480"/>
+            <a:off x="4563770" y="4379976"/>
+            <a:ext cx="3064154" cy="1161288"/>
           </a:xfrm>
           <a:prstGeom prst="rect">
             <a:avLst/>
@@ -6117,12 +7016,15 @@
           <a:lstStyle/>
           <a:p>
             <a:pPr algn="l">
+              <a:lnSpc>
+                <a:spcPct val="118000"/>
+              </a:lnSpc>
               <a:spcAft>
                 <a:spcPts val="600"/>
               </a:spcAft>
             </a:pPr>
             <a:r>
-              <a:rPr sz="1700" b="0" i="0">
+              <a:rPr sz="2000" b="0" i="0">
                 <a:solidFill>
                   <a:srgbClr val="0E1B36"/>
                 </a:solidFill>
@@ -6132,9 +7034,13 @@
             </a:r>
           </a:p>
           <a:p>
-            <a:pPr algn="l"/>
-            <a:r>
-              <a:rPr sz="1000" b="0" i="0">
+            <a:pPr algn="l">
+              <a:lnSpc>
+                <a:spcPct val="140000"/>
+              </a:lnSpc>
+            </a:pPr>
+            <a:r>
+              <a:rPr sz="1100" b="0" i="0">
                 <a:solidFill>
                   <a:srgbClr val="1C2638"/>
                 </a:solidFill>
@@ -6147,14 +7053,14 @@
       </p:sp>
       <p:sp>
         <p:nvSpPr>
-          <p:cNvPr id="9" name="Rectangle 8"/>
+          <p:cNvPr id="11" name="Rectangle 10"/>
           <p:cNvSpPr/>
           <p:nvPr/>
         </p:nvSpPr>
         <p:spPr>
           <a:xfrm>
-            <a:off x="8036356" y="3840480"/>
-            <a:ext cx="3515258" cy="1783080"/>
+            <a:off x="8021116" y="4251960"/>
+            <a:ext cx="3393338" cy="1417320"/>
           </a:xfrm>
           <a:prstGeom prst="rect">
             <a:avLst/>
@@ -6191,14 +7097,14 @@
       </p:sp>
       <p:sp>
         <p:nvSpPr>
-          <p:cNvPr id="10" name="Rectangle 9"/>
+          <p:cNvPr id="12" name="Rectangle 11"/>
           <p:cNvSpPr/>
           <p:nvPr/>
         </p:nvSpPr>
         <p:spPr>
           <a:xfrm>
-            <a:off x="8036356" y="3840480"/>
-            <a:ext cx="3515258" cy="38100"/>
+            <a:off x="8021116" y="4251960"/>
+            <a:ext cx="3393338" cy="38100"/>
           </a:xfrm>
           <a:prstGeom prst="rect">
             <a:avLst/>
@@ -6235,14 +7141,14 @@
       </p:sp>
       <p:sp>
         <p:nvSpPr>
-          <p:cNvPr id="11" name="TextBox 10"/>
+          <p:cNvPr id="13" name="TextBox 12"/>
           <p:cNvSpPr txBox="1"/>
           <p:nvPr/>
         </p:nvSpPr>
         <p:spPr>
           <a:xfrm>
-            <a:off x="8200948" y="3968496"/>
-            <a:ext cx="3186074" cy="1554480"/>
+            <a:off x="8185708" y="4379976"/>
+            <a:ext cx="3064154" cy="1161288"/>
           </a:xfrm>
           <a:prstGeom prst="rect">
             <a:avLst/>
@@ -6256,12 +7162,15 @@
           <a:lstStyle/>
           <a:p>
             <a:pPr algn="l">
+              <a:lnSpc>
+                <a:spcPct val="118000"/>
+              </a:lnSpc>
               <a:spcAft>
                 <a:spcPts val="600"/>
               </a:spcAft>
             </a:pPr>
             <a:r>
-              <a:rPr sz="1700" b="0" i="0">
+              <a:rPr sz="2000" b="0" i="0">
                 <a:solidFill>
                   <a:srgbClr val="0E1B36"/>
                 </a:solidFill>
@@ -6271,9 +7180,13 @@
             </a:r>
           </a:p>
           <a:p>
-            <a:pPr algn="l"/>
-            <a:r>
-              <a:rPr sz="1000" b="0" i="0">
+            <a:pPr algn="l">
+              <a:lnSpc>
+                <a:spcPct val="140000"/>
+              </a:lnSpc>
+            </a:pPr>
+            <a:r>
+              <a:rPr sz="1100" b="0" i="0">
                 <a:solidFill>
                   <a:srgbClr val="1C2638"/>
                 </a:solidFill>
@@ -6286,14 +7199,14 @@
       </p:sp>
       <p:sp>
         <p:nvSpPr>
-          <p:cNvPr id="12" name="Rectangle 11"/>
+          <p:cNvPr id="14" name="Rectangle 13"/>
           <p:cNvSpPr/>
           <p:nvPr/>
         </p:nvSpPr>
         <p:spPr>
           <a:xfrm>
-            <a:off x="640080" y="5852160"/>
-            <a:ext cx="10911535" cy="777240"/>
+            <a:off x="777240" y="5852160"/>
+            <a:ext cx="10637215" cy="594360"/>
           </a:xfrm>
           <a:prstGeom prst="rect">
             <a:avLst/>
@@ -6321,12 +7234,16 @@
           </a:fontRef>
         </p:style>
         <p:txBody>
-          <a:bodyPr rtlCol="0" anchor="ctr" lIns="152400" rIns="152400" tIns="76200" bIns="76200"/>
-          <a:lstStyle/>
-          <a:p>
-            <a:pPr algn="l"/>
-            <a:r>
-              <a:rPr sz="1400" b="0" i="0">
+          <a:bodyPr rtlCol="0" anchor="ctr" lIns="177800" rIns="177800" tIns="50800" bIns="50800" wrap="square"/>
+          <a:lstStyle/>
+          <a:p>
+            <a:pPr algn="l">
+              <a:lnSpc>
+                <a:spcPct val="125000"/>
+              </a:lnSpc>
+            </a:pPr>
+            <a:r>
+              <a:rPr sz="1600" b="0" i="0">
                 <a:solidFill>
                   <a:srgbClr val="0E1B36"/>
                 </a:solidFill>
@@ -6371,8 +7288,8 @@
         </p:nvSpPr>
         <p:spPr>
           <a:xfrm>
-            <a:off x="640080" y="502920"/>
-            <a:ext cx="10911535" cy="1463040"/>
+            <a:off x="777240" y="274320"/>
+            <a:ext cx="7315200" cy="320040"/>
           </a:xfrm>
           <a:prstGeom prst="rect">
             <a:avLst/>
@@ -6380,156 +7297,34 @@
           <a:noFill/>
         </p:spPr>
         <p:txBody>
-          <a:bodyPr wrap="square" lIns="0" rIns="0" tIns="0" bIns="0" anchor="t">
+          <a:bodyPr wrap="square" lIns="0" rIns="0" tIns="0" bIns="0" anchor="ctr">
             <a:spAutoFit/>
           </a:bodyPr>
           <a:lstStyle/>
           <a:p>
-            <a:pPr algn="l">
-              <a:spcAft>
-                <a:spcPts val="1400"/>
-              </a:spcAft>
-            </a:pPr>
-            <a:r>
-              <a:rPr sz="1100" b="1" i="0" spc="240">
-                <a:solidFill>
-                  <a:srgbClr val="1F3D88"/>
+            <a:pPr algn="l"/>
+            <a:r>
+              <a:rPr sz="1100" b="1" i="0" spc="300">
+                <a:solidFill>
+                  <a:srgbClr val="0E1B36"/>
                 </a:solidFill>
                 <a:latin typeface="JetBrains Mono"/>
               </a:rPr>
-              <a:t>HOW WE BUILD IT</a:t>
-            </a:r>
-          </a:p>
-          <a:p>
-            <a:pPr algn="l">
-              <a:spcAft>
-                <a:spcPts val="1400"/>
-              </a:spcAft>
-            </a:pPr>
-            <a:r>
-              <a:rPr sz="2400" b="0" i="0">
-                <a:solidFill>
-                  <a:srgbClr val="0E1B36"/>
-                </a:solidFill>
-                <a:latin typeface="Cormorant Garamond"/>
-              </a:rPr>
-              <a:t>A three-phase arc, with each phase committing only what the prior phase has earned.</a:t>
-            </a:r>
-          </a:p>
-        </p:txBody>
-      </p:sp>
-      <p:sp>
-        <p:nvSpPr>
-          <p:cNvPr id="3" name="TextBox 2"/>
-          <p:cNvSpPr txBox="1"/>
-          <p:nvPr/>
-        </p:nvSpPr>
-        <p:spPr>
-          <a:xfrm>
-            <a:off x="640080" y="2377440"/>
-            <a:ext cx="822960" cy="1325880"/>
-          </a:xfrm>
-          <a:prstGeom prst="rect">
-            <a:avLst/>
-          </a:prstGeom>
-          <a:noFill/>
-        </p:spPr>
-        <p:txBody>
-          <a:bodyPr wrap="square" lIns="0" rIns="0" tIns="0" bIns="0" anchor="t">
-            <a:spAutoFit/>
-          </a:bodyPr>
-          <a:lstStyle/>
-          <a:p>
-            <a:pPr algn="l"/>
-            <a:r>
-              <a:rPr sz="4000" b="0" i="0">
-                <a:solidFill>
-                  <a:srgbClr val="1F3D88"/>
-                </a:solidFill>
-                <a:latin typeface="Cormorant Garamond"/>
-              </a:rPr>
-              <a:t>01</a:t>
-            </a:r>
-          </a:p>
-        </p:txBody>
-      </p:sp>
-      <p:sp>
-        <p:nvSpPr>
-          <p:cNvPr id="4" name="TextBox 3"/>
-          <p:cNvSpPr txBox="1"/>
-          <p:nvPr/>
-        </p:nvSpPr>
-        <p:spPr>
-          <a:xfrm>
-            <a:off x="1737360" y="2377440"/>
-            <a:ext cx="9814255" cy="1325880"/>
-          </a:xfrm>
-          <a:prstGeom prst="rect">
-            <a:avLst/>
-          </a:prstGeom>
-          <a:noFill/>
-        </p:spPr>
-        <p:txBody>
-          <a:bodyPr wrap="square" lIns="0" rIns="0" tIns="0" bIns="0" anchor="t">
-            <a:spAutoFit/>
-          </a:bodyPr>
-          <a:lstStyle/>
-          <a:p>
-            <a:pPr algn="l">
-              <a:spcAft>
-                <a:spcPts val="300"/>
-              </a:spcAft>
-            </a:pPr>
-            <a:r>
-              <a:rPr sz="900" b="1" i="0" spc="200">
-                <a:solidFill>
-                  <a:srgbClr val="5C6577"/>
-                </a:solidFill>
-                <a:latin typeface="JetBrains Mono"/>
-              </a:rPr>
-              <a:t>DISCOVERY · 4–6 WEEKS</a:t>
-            </a:r>
-          </a:p>
-          <a:p>
-            <a:pPr algn="l">
-              <a:spcAft>
-                <a:spcPts val="400"/>
-              </a:spcAft>
-            </a:pPr>
-            <a:r>
-              <a:rPr sz="1700" b="0" i="0">
-                <a:solidFill>
-                  <a:srgbClr val="0E1B36"/>
-                </a:solidFill>
-                <a:latin typeface="Cormorant Garamond"/>
-              </a:rPr>
-              <a:t>Listen, scope, and lay the foundation.</a:t>
-            </a:r>
-          </a:p>
-          <a:p>
-            <a:pPr algn="l"/>
-            <a:r>
-              <a:rPr sz="1050" b="0" i="0">
-                <a:solidFill>
-                  <a:srgbClr val="1C2638"/>
-                </a:solidFill>
-                <a:latin typeface="Inter"/>
-              </a:rPr>
-              <a:t>A focused engagement that interviews the stakeholders, surveys the peer landscape, identifies the partner-integration vectors, and produces a draft scope-and-plan document for Phase 2. Light-footprint, decisive, designed so anyone reading it can see exactly what they would be funding and why.</a:t>
-            </a:r>
-          </a:p>
-        </p:txBody>
-      </p:sp>
-      <p:sp>
-        <p:nvSpPr>
-          <p:cNvPr id="5" name="Rectangle 4"/>
+              <a:t>SAN FRANCISCO · CIVIC ART MAP</a:t>
+            </a:r>
+          </a:p>
+        </p:txBody>
+      </p:sp>
+      <p:sp>
+        <p:nvSpPr>
+          <p:cNvPr id="3" name="Rectangle 2"/>
           <p:cNvSpPr/>
           <p:nvPr/>
         </p:nvSpPr>
         <p:spPr>
           <a:xfrm>
-            <a:off x="640080" y="3630168"/>
-            <a:ext cx="10911535" cy="9525"/>
+            <a:off x="0" y="749808"/>
+            <a:ext cx="12191695" cy="9525"/>
           </a:xfrm>
           <a:prstGeom prst="rect">
             <a:avLst/>
@@ -6566,14 +7361,14 @@
       </p:sp>
       <p:sp>
         <p:nvSpPr>
-          <p:cNvPr id="6" name="TextBox 5"/>
+          <p:cNvPr id="4" name="TextBox 3"/>
           <p:cNvSpPr txBox="1"/>
           <p:nvPr/>
         </p:nvSpPr>
         <p:spPr>
           <a:xfrm>
-            <a:off x="640080" y="3703320"/>
-            <a:ext cx="822960" cy="1325880"/>
+            <a:off x="777240" y="1097280"/>
+            <a:ext cx="10637215" cy="1645920"/>
           </a:xfrm>
           <a:prstGeom prst="rect">
             <a:avLst/>
@@ -6586,29 +7381,84 @@
           </a:bodyPr>
           <a:lstStyle/>
           <a:p>
+            <a:pPr algn="l">
+              <a:spcAft>
+                <a:spcPts val="1400"/>
+              </a:spcAft>
+            </a:pPr>
+            <a:r>
+              <a:rPr sz="1100" b="1" i="0" spc="240">
+                <a:solidFill>
+                  <a:srgbClr val="1F3D88"/>
+                </a:solidFill>
+                <a:latin typeface="JetBrains Mono"/>
+              </a:rPr>
+              <a:t>HOW WE BUILD IT</a:t>
+            </a:r>
+          </a:p>
+          <a:p>
+            <a:pPr algn="l">
+              <a:spcAft>
+                <a:spcPts val="1400"/>
+              </a:spcAft>
+            </a:pPr>
+            <a:r>
+              <a:rPr sz="3200" b="0" i="0">
+                <a:solidFill>
+                  <a:srgbClr val="0E1B36"/>
+                </a:solidFill>
+                <a:latin typeface="Cormorant Garamond"/>
+              </a:rPr>
+              <a:t>A three-phase arc, with each phase committing only what the prior phase has earned.</a:t>
+            </a:r>
+          </a:p>
+        </p:txBody>
+      </p:sp>
+      <p:sp>
+        <p:nvSpPr>
+          <p:cNvPr id="5" name="TextBox 4"/>
+          <p:cNvSpPr txBox="1"/>
+          <p:nvPr/>
+        </p:nvSpPr>
+        <p:spPr>
+          <a:xfrm>
+            <a:off x="777240" y="3246120"/>
+            <a:ext cx="960120" cy="1097280"/>
+          </a:xfrm>
+          <a:prstGeom prst="rect">
+            <a:avLst/>
+          </a:prstGeom>
+          <a:noFill/>
+        </p:spPr>
+        <p:txBody>
+          <a:bodyPr wrap="square" lIns="0" rIns="0" tIns="0" bIns="0" anchor="t">
+            <a:spAutoFit/>
+          </a:bodyPr>
+          <a:lstStyle/>
+          <a:p>
             <a:pPr algn="l"/>
             <a:r>
-              <a:rPr sz="4000" b="0" i="0">
+              <a:rPr sz="4600" b="0" i="0">
                 <a:solidFill>
                   <a:srgbClr val="1F3D88"/>
                 </a:solidFill>
                 <a:latin typeface="Cormorant Garamond"/>
               </a:rPr>
-              <a:t>02</a:t>
-            </a:r>
-          </a:p>
-        </p:txBody>
-      </p:sp>
-      <p:sp>
-        <p:nvSpPr>
-          <p:cNvPr id="7" name="TextBox 6"/>
+              <a:t>01</a:t>
+            </a:r>
+          </a:p>
+        </p:txBody>
+      </p:sp>
+      <p:sp>
+        <p:nvSpPr>
+          <p:cNvPr id="6" name="TextBox 5"/>
           <p:cNvSpPr txBox="1"/>
           <p:nvPr/>
         </p:nvSpPr>
         <p:spPr>
           <a:xfrm>
-            <a:off x="1737360" y="3703320"/>
-            <a:ext cx="9814255" cy="1325880"/>
+            <a:off x="2057400" y="3291840"/>
+            <a:ext cx="9357055" cy="1097280"/>
           </a:xfrm>
           <a:prstGeom prst="rect">
             <a:avLst/>
@@ -6627,55 +7477,62 @@
               </a:spcAft>
             </a:pPr>
             <a:r>
-              <a:rPr sz="900" b="1" i="0" spc="200">
+              <a:rPr sz="1000" b="1" i="0" spc="240">
                 <a:solidFill>
                   <a:srgbClr val="5C6577"/>
                 </a:solidFill>
                 <a:latin typeface="JetBrains Mono"/>
               </a:rPr>
-              <a:t>PROTOTYPE · 8–12 WEEKS</a:t>
+              <a:t>DISCOVERY · 4–6 WEEKS</a:t>
             </a:r>
           </a:p>
           <a:p>
             <a:pPr algn="l">
+              <a:lnSpc>
+                <a:spcPct val="118000"/>
+              </a:lnSpc>
               <a:spcAft>
                 <a:spcPts val="400"/>
               </a:spcAft>
             </a:pPr>
             <a:r>
-              <a:rPr sz="1700" b="0" i="0">
+              <a:rPr sz="2000" b="0" i="0">
                 <a:solidFill>
                   <a:srgbClr val="0E1B36"/>
                 </a:solidFill>
                 <a:latin typeface="Cormorant Garamond"/>
               </a:rPr>
-              <a:t>Vibe-code a working version. Put it in real hands.</a:t>
-            </a:r>
-          </a:p>
-          <a:p>
-            <a:pPr algn="l"/>
-            <a:r>
-              <a:rPr sz="1050" b="0" i="0">
+              <a:t>Listen, scope, and lay the foundation.</a:t>
+            </a:r>
+          </a:p>
+          <a:p>
+            <a:pPr algn="l">
+              <a:lnSpc>
+                <a:spcPct val="142000"/>
+              </a:lnSpc>
+            </a:pPr>
+            <a:r>
+              <a:rPr sz="1150" b="0" i="0">
                 <a:solidFill>
                   <a:srgbClr val="1C2638"/>
                 </a:solidFill>
                 <a:latin typeface="Inter"/>
               </a:rPr>
-              <a:t>A working web application with a curated subset of the city's institutions, the first version of the interpretation layer, and the first integrations with the most willing tech partners. Tested with real users, iterated weekly. The deliverable is not a deck; it is a thing people use.</a:t>
-            </a:r>
-          </a:p>
-        </p:txBody>
-      </p:sp>
-      <p:sp>
-        <p:nvSpPr>
-          <p:cNvPr id="8" name="Rectangle 7"/>
+              <a:t>A focused engagement that interviews the stakeholders, surveys the peer landscape, identifies the partner-integration vectors, and produces a draft scope-and-plan document for Phase 2. Light-footprint, decisive, designed so anyone reading it can see exactly what they would be funding and why.</a:t>
+            </a:r>
+          </a:p>
+        </p:txBody>
+      </p:sp>
+      <p:sp>
+        <p:nvSpPr>
+          <p:cNvPr id="7" name="Rectangle 6"/>
           <p:cNvSpPr/>
           <p:nvPr/>
         </p:nvSpPr>
         <p:spPr>
           <a:xfrm>
-            <a:off x="640080" y="4956048"/>
-            <a:ext cx="10911535" cy="9525"/>
+            <a:off x="777240" y="4297680"/>
+            <a:ext cx="10637215" cy="9525"/>
           </a:xfrm>
           <a:prstGeom prst="rect">
             <a:avLst/>
@@ -6712,14 +7569,14 @@
       </p:sp>
       <p:sp>
         <p:nvSpPr>
-          <p:cNvPr id="9" name="TextBox 8"/>
+          <p:cNvPr id="8" name="TextBox 7"/>
           <p:cNvSpPr txBox="1"/>
           <p:nvPr/>
         </p:nvSpPr>
         <p:spPr>
           <a:xfrm>
-            <a:off x="640080" y="5029200"/>
-            <a:ext cx="822960" cy="1325880"/>
+            <a:off x="777240" y="4343400"/>
+            <a:ext cx="960120" cy="1097280"/>
           </a:xfrm>
           <a:prstGeom prst="rect">
             <a:avLst/>
@@ -6734,27 +7591,27 @@
           <a:p>
             <a:pPr algn="l"/>
             <a:r>
-              <a:rPr sz="4000" b="0" i="0">
+              <a:rPr sz="4600" b="0" i="0">
                 <a:solidFill>
                   <a:srgbClr val="1F3D88"/>
                 </a:solidFill>
                 <a:latin typeface="Cormorant Garamond"/>
               </a:rPr>
-              <a:t>03</a:t>
-            </a:r>
-          </a:p>
-        </p:txBody>
-      </p:sp>
-      <p:sp>
-        <p:nvSpPr>
-          <p:cNvPr id="10" name="TextBox 9"/>
+              <a:t>02</a:t>
+            </a:r>
+          </a:p>
+        </p:txBody>
+      </p:sp>
+      <p:sp>
+        <p:nvSpPr>
+          <p:cNvPr id="9" name="TextBox 8"/>
           <p:cNvSpPr txBox="1"/>
           <p:nvPr/>
         </p:nvSpPr>
         <p:spPr>
           <a:xfrm>
-            <a:off x="1737360" y="5029200"/>
-            <a:ext cx="9814255" cy="1325880"/>
+            <a:off x="2057400" y="4389120"/>
+            <a:ext cx="9357055" cy="1097280"/>
           </a:xfrm>
           <a:prstGeom prst="rect">
             <a:avLst/>
@@ -6773,35 +7630,195 @@
               </a:spcAft>
             </a:pPr>
             <a:r>
-              <a:rPr sz="900" b="1" i="0" spc="200">
+              <a:rPr sz="1000" b="1" i="0" spc="240">
                 <a:solidFill>
                   <a:srgbClr val="5C6577"/>
                 </a:solidFill>
                 <a:latin typeface="JetBrains Mono"/>
               </a:rPr>
-              <a:t>LAUNCH + STEWARD · OPEN STRUCTURE</a:t>
+              <a:t>PROTOTYPE · 8–12 WEEKS</a:t>
             </a:r>
           </a:p>
           <a:p>
             <a:pPr algn="l">
+              <a:lnSpc>
+                <a:spcPct val="118000"/>
+              </a:lnSpc>
               <a:spcAft>
                 <a:spcPts val="400"/>
               </a:spcAft>
             </a:pPr>
             <a:r>
-              <a:rPr sz="1700" b="0" i="0">
+              <a:rPr sz="2000" b="0" i="0">
                 <a:solidFill>
                   <a:srgbClr val="0E1B36"/>
                 </a:solidFill>
                 <a:latin typeface="Cormorant Garamond"/>
               </a:rPr>
+              <a:t>Vibe-code a working version. Put it in real hands.</a:t>
+            </a:r>
+          </a:p>
+          <a:p>
+            <a:pPr algn="l">
+              <a:lnSpc>
+                <a:spcPct val="142000"/>
+              </a:lnSpc>
+            </a:pPr>
+            <a:r>
+              <a:rPr sz="1150" b="0" i="0">
+                <a:solidFill>
+                  <a:srgbClr val="1C2638"/>
+                </a:solidFill>
+                <a:latin typeface="Inter"/>
+              </a:rPr>
+              <a:t>A working web application with a curated subset of the city's institutions, the first version of the interpretation layer, and the first integrations with the most willing tech partners. Tested with real users, iterated weekly. The deliverable is not a deck; it is a thing people use.</a:t>
+            </a:r>
+          </a:p>
+        </p:txBody>
+      </p:sp>
+      <p:sp>
+        <p:nvSpPr>
+          <p:cNvPr id="10" name="Rectangle 9"/>
+          <p:cNvSpPr/>
+          <p:nvPr/>
+        </p:nvSpPr>
+        <p:spPr>
+          <a:xfrm>
+            <a:off x="777240" y="5394960"/>
+            <a:ext cx="10637215" cy="9525"/>
+          </a:xfrm>
+          <a:prstGeom prst="rect">
+            <a:avLst/>
+          </a:prstGeom>
+          <a:solidFill>
+            <a:srgbClr val="D6DEEA"/>
+          </a:solidFill>
+          <a:ln>
+            <a:noFill/>
+          </a:ln>
+          <a:effectLst/>
+        </p:spPr>
+        <p:style>
+          <a:lnRef idx="1">
+            <a:schemeClr val="accent1"/>
+          </a:lnRef>
+          <a:fillRef idx="3">
+            <a:schemeClr val="accent1"/>
+          </a:fillRef>
+          <a:effectRef idx="2">
+            <a:schemeClr val="accent1"/>
+          </a:effectRef>
+          <a:fontRef idx="minor">
+            <a:schemeClr val="lt1"/>
+          </a:fontRef>
+        </p:style>
+        <p:txBody>
+          <a:bodyPr rtlCol="0" anchor="ctr"/>
+          <a:lstStyle/>
+          <a:p>
+            <a:pPr algn="ctr"/>
+          </a:p>
+        </p:txBody>
+      </p:sp>
+      <p:sp>
+        <p:nvSpPr>
+          <p:cNvPr id="11" name="TextBox 10"/>
+          <p:cNvSpPr txBox="1"/>
+          <p:nvPr/>
+        </p:nvSpPr>
+        <p:spPr>
+          <a:xfrm>
+            <a:off x="777240" y="5440680"/>
+            <a:ext cx="960120" cy="1097280"/>
+          </a:xfrm>
+          <a:prstGeom prst="rect">
+            <a:avLst/>
+          </a:prstGeom>
+          <a:noFill/>
+        </p:spPr>
+        <p:txBody>
+          <a:bodyPr wrap="square" lIns="0" rIns="0" tIns="0" bIns="0" anchor="t">
+            <a:spAutoFit/>
+          </a:bodyPr>
+          <a:lstStyle/>
+          <a:p>
+            <a:pPr algn="l"/>
+            <a:r>
+              <a:rPr sz="4600" b="0" i="0">
+                <a:solidFill>
+                  <a:srgbClr val="1F3D88"/>
+                </a:solidFill>
+                <a:latin typeface="Cormorant Garamond"/>
+              </a:rPr>
+              <a:t>03</a:t>
+            </a:r>
+          </a:p>
+        </p:txBody>
+      </p:sp>
+      <p:sp>
+        <p:nvSpPr>
+          <p:cNvPr id="12" name="TextBox 11"/>
+          <p:cNvSpPr txBox="1"/>
+          <p:nvPr/>
+        </p:nvSpPr>
+        <p:spPr>
+          <a:xfrm>
+            <a:off x="2057400" y="5486400"/>
+            <a:ext cx="9357055" cy="1097280"/>
+          </a:xfrm>
+          <a:prstGeom prst="rect">
+            <a:avLst/>
+          </a:prstGeom>
+          <a:noFill/>
+        </p:spPr>
+        <p:txBody>
+          <a:bodyPr wrap="square" lIns="0" rIns="0" tIns="0" bIns="0" anchor="t">
+            <a:spAutoFit/>
+          </a:bodyPr>
+          <a:lstStyle/>
+          <a:p>
+            <a:pPr algn="l">
+              <a:spcAft>
+                <a:spcPts val="300"/>
+              </a:spcAft>
+            </a:pPr>
+            <a:r>
+              <a:rPr sz="1000" b="1" i="0" spc="240">
+                <a:solidFill>
+                  <a:srgbClr val="5C6577"/>
+                </a:solidFill>
+                <a:latin typeface="JetBrains Mono"/>
+              </a:rPr>
+              <a:t>LAUNCH + STEWARD · OPEN STRUCTURE</a:t>
+            </a:r>
+          </a:p>
+          <a:p>
+            <a:pPr algn="l">
+              <a:lnSpc>
+                <a:spcPct val="118000"/>
+              </a:lnSpc>
+              <a:spcAft>
+                <a:spcPts val="400"/>
+              </a:spcAft>
+            </a:pPr>
+            <a:r>
+              <a:rPr sz="2000" b="0" i="0">
+                <a:solidFill>
+                  <a:srgbClr val="0E1B36"/>
+                </a:solidFill>
+                <a:latin typeface="Cormorant Garamond"/>
+              </a:rPr>
               <a:t>Ship the public utility. Make it last.</a:t>
             </a:r>
           </a:p>
           <a:p>
-            <a:pPr algn="l"/>
-            <a:r>
-              <a:rPr sz="1050" b="0" i="0">
+            <a:pPr algn="l">
+              <a:lnSpc>
+                <a:spcPct val="142000"/>
+              </a:lnSpc>
+            </a:pPr>
+            <a:r>
+              <a:rPr sz="1150" b="0" i="0">
                 <a:solidFill>
                   <a:srgbClr val="1C2638"/>
                 </a:solidFill>
@@ -6846,8 +7863,87 @@
         </p:nvSpPr>
         <p:spPr>
           <a:xfrm>
-            <a:off x="640080" y="502920"/>
-            <a:ext cx="10911535" cy="2194560"/>
+            <a:off x="777240" y="274320"/>
+            <a:ext cx="7315200" cy="320040"/>
+          </a:xfrm>
+          <a:prstGeom prst="rect">
+            <a:avLst/>
+          </a:prstGeom>
+          <a:noFill/>
+        </p:spPr>
+        <p:txBody>
+          <a:bodyPr wrap="square" lIns="0" rIns="0" tIns="0" bIns="0" anchor="ctr">
+            <a:spAutoFit/>
+          </a:bodyPr>
+          <a:lstStyle/>
+          <a:p>
+            <a:pPr algn="l"/>
+            <a:r>
+              <a:rPr sz="1100" b="1" i="0" spc="300">
+                <a:solidFill>
+                  <a:srgbClr val="0E1B36"/>
+                </a:solidFill>
+                <a:latin typeface="JetBrains Mono"/>
+              </a:rPr>
+              <a:t>SAN FRANCISCO · CIVIC ART MAP</a:t>
+            </a:r>
+          </a:p>
+        </p:txBody>
+      </p:sp>
+      <p:sp>
+        <p:nvSpPr>
+          <p:cNvPr id="3" name="Rectangle 2"/>
+          <p:cNvSpPr/>
+          <p:nvPr/>
+        </p:nvSpPr>
+        <p:spPr>
+          <a:xfrm>
+            <a:off x="0" y="749808"/>
+            <a:ext cx="12191695" cy="9525"/>
+          </a:xfrm>
+          <a:prstGeom prst="rect">
+            <a:avLst/>
+          </a:prstGeom>
+          <a:solidFill>
+            <a:srgbClr val="D6DEEA"/>
+          </a:solidFill>
+          <a:ln>
+            <a:noFill/>
+          </a:ln>
+          <a:effectLst/>
+        </p:spPr>
+        <p:style>
+          <a:lnRef idx="1">
+            <a:schemeClr val="accent1"/>
+          </a:lnRef>
+          <a:fillRef idx="3">
+            <a:schemeClr val="accent1"/>
+          </a:fillRef>
+          <a:effectRef idx="2">
+            <a:schemeClr val="accent1"/>
+          </a:effectRef>
+          <a:fontRef idx="minor">
+            <a:schemeClr val="lt1"/>
+          </a:fontRef>
+        </p:style>
+        <p:txBody>
+          <a:bodyPr rtlCol="0" anchor="ctr"/>
+          <a:lstStyle/>
+          <a:p>
+            <a:pPr algn="ctr"/>
+          </a:p>
+        </p:txBody>
+      </p:sp>
+      <p:sp>
+        <p:nvSpPr>
+          <p:cNvPr id="4" name="TextBox 3"/>
+          <p:cNvSpPr txBox="1"/>
+          <p:nvPr/>
+        </p:nvSpPr>
+        <p:spPr>
+          <a:xfrm>
+            <a:off x="777240" y="1097280"/>
+            <a:ext cx="10637215" cy="2286000"/>
           </a:xfrm>
           <a:prstGeom prst="rect">
             <a:avLst/>
@@ -6882,7 +7978,7 @@
               </a:spcAft>
             </a:pPr>
             <a:r>
-              <a:rPr sz="2200" b="0" i="0">
+              <a:rPr sz="3200" b="0" i="0">
                 <a:solidFill>
                   <a:srgbClr val="0E1B36"/>
                 </a:solidFill>
@@ -6893,12 +7989,15 @@
           </a:p>
           <a:p>
             <a:pPr algn="l">
-              <a:spcAft>
-                <a:spcPts val="1000"/>
-              </a:spcAft>
+              <a:lnSpc>
+                <a:spcPct val="142000"/>
+              </a:lnSpc>
+              <a:spcBef>
+                <a:spcPts val="400"/>
+              </a:spcBef>
             </a:pPr>
             <a:r>
-              <a:rPr sz="1200" b="0" i="0">
+              <a:rPr sz="1300" b="0" i="0">
                 <a:solidFill>
                   <a:srgbClr val="1C2638"/>
                 </a:solidFill>
@@ -6911,14 +8010,14 @@
       </p:sp>
       <p:sp>
         <p:nvSpPr>
-          <p:cNvPr id="3" name="Rectangle 2"/>
+          <p:cNvPr id="5" name="Rectangle 4"/>
           <p:cNvSpPr/>
           <p:nvPr/>
         </p:nvSpPr>
         <p:spPr>
           <a:xfrm>
-            <a:off x="640080" y="3246120"/>
-            <a:ext cx="10911535" cy="3012694"/>
+            <a:off x="777240" y="3520440"/>
+            <a:ext cx="10637215" cy="3012694"/>
           </a:xfrm>
           <a:prstGeom prst="rect">
             <a:avLst/>
@@ -6957,13 +8056,13 @@
       </p:sp>
       <p:sp>
         <p:nvSpPr>
-          <p:cNvPr id="4" name="TextBox 3"/>
+          <p:cNvPr id="6" name="TextBox 5"/>
           <p:cNvSpPr txBox="1"/>
           <p:nvPr/>
         </p:nvSpPr>
         <p:spPr>
           <a:xfrm>
-            <a:off x="804672" y="3410712"/>
+            <a:off x="941832" y="3685032"/>
             <a:ext cx="1828800" cy="1005840"/>
           </a:xfrm>
           <a:prstGeom prst="rect">
@@ -6992,14 +8091,14 @@
       </p:sp>
       <p:sp>
         <p:nvSpPr>
-          <p:cNvPr id="5" name="TextBox 4"/>
+          <p:cNvPr id="7" name="TextBox 6"/>
           <p:cNvSpPr txBox="1"/>
           <p:nvPr/>
         </p:nvSpPr>
         <p:spPr>
           <a:xfrm>
-            <a:off x="2862072" y="3410712"/>
-            <a:ext cx="8524951" cy="1005840"/>
+            <a:off x="2999232" y="3685032"/>
+            <a:ext cx="8250631" cy="1005840"/>
           </a:xfrm>
           <a:prstGeom prst="rect">
             <a:avLst/>
@@ -7165,14 +8264,14 @@
       </p:sp>
       <p:sp>
         <p:nvSpPr>
-          <p:cNvPr id="6" name="Rectangle 5"/>
+          <p:cNvPr id="8" name="Rectangle 7"/>
           <p:cNvSpPr/>
           <p:nvPr/>
         </p:nvSpPr>
         <p:spPr>
           <a:xfrm>
-            <a:off x="804672" y="4416552"/>
-            <a:ext cx="10582351" cy="6350"/>
+            <a:off x="941832" y="4690872"/>
+            <a:ext cx="10308031" cy="6350"/>
           </a:xfrm>
           <a:prstGeom prst="rect">
             <a:avLst/>
@@ -7209,13 +8308,13 @@
       </p:sp>
       <p:sp>
         <p:nvSpPr>
-          <p:cNvPr id="7" name="TextBox 6"/>
+          <p:cNvPr id="9" name="TextBox 8"/>
           <p:cNvSpPr txBox="1"/>
           <p:nvPr/>
         </p:nvSpPr>
         <p:spPr>
           <a:xfrm>
-            <a:off x="804672" y="4422902"/>
+            <a:off x="941832" y="4697222"/>
             <a:ext cx="1828800" cy="274320"/>
           </a:xfrm>
           <a:prstGeom prst="rect">
@@ -7244,14 +8343,14 @@
       </p:sp>
       <p:sp>
         <p:nvSpPr>
-          <p:cNvPr id="8" name="TextBox 7"/>
+          <p:cNvPr id="10" name="TextBox 9"/>
           <p:cNvSpPr txBox="1"/>
           <p:nvPr/>
         </p:nvSpPr>
         <p:spPr>
           <a:xfrm>
-            <a:off x="2862072" y="4422902"/>
-            <a:ext cx="8524951" cy="274320"/>
+            <a:off x="2999232" y="4697222"/>
+            <a:ext cx="8250631" cy="274320"/>
           </a:xfrm>
           <a:prstGeom prst="rect">
             <a:avLst/>
@@ -7279,14 +8378,14 @@
       </p:sp>
       <p:sp>
         <p:nvSpPr>
-          <p:cNvPr id="9" name="Rectangle 8"/>
+          <p:cNvPr id="11" name="Rectangle 10"/>
           <p:cNvSpPr/>
           <p:nvPr/>
         </p:nvSpPr>
         <p:spPr>
           <a:xfrm>
-            <a:off x="804672" y="4697222"/>
-            <a:ext cx="10582351" cy="6350"/>
+            <a:off x="941832" y="4971542"/>
+            <a:ext cx="10308031" cy="6350"/>
           </a:xfrm>
           <a:prstGeom prst="rect">
             <a:avLst/>
@@ -7323,13 +8422,13 @@
       </p:sp>
       <p:sp>
         <p:nvSpPr>
-          <p:cNvPr id="10" name="TextBox 9"/>
+          <p:cNvPr id="12" name="TextBox 11"/>
           <p:cNvSpPr txBox="1"/>
           <p:nvPr/>
         </p:nvSpPr>
         <p:spPr>
           <a:xfrm>
-            <a:off x="804672" y="4703572"/>
+            <a:off x="941832" y="4977892"/>
             <a:ext cx="1828800" cy="274320"/>
           </a:xfrm>
           <a:prstGeom prst="rect">
@@ -7358,14 +8457,14 @@
       </p:sp>
       <p:sp>
         <p:nvSpPr>
-          <p:cNvPr id="11" name="TextBox 10"/>
+          <p:cNvPr id="13" name="TextBox 12"/>
           <p:cNvSpPr txBox="1"/>
           <p:nvPr/>
         </p:nvSpPr>
         <p:spPr>
           <a:xfrm>
-            <a:off x="2862072" y="4703572"/>
-            <a:ext cx="8524951" cy="274320"/>
+            <a:off x="2999232" y="4977892"/>
+            <a:ext cx="8250631" cy="274320"/>
           </a:xfrm>
           <a:prstGeom prst="rect">
             <a:avLst/>
@@ -7393,14 +8492,14 @@
       </p:sp>
       <p:sp>
         <p:nvSpPr>
-          <p:cNvPr id="12" name="Rectangle 11"/>
+          <p:cNvPr id="14" name="Rectangle 13"/>
           <p:cNvSpPr/>
           <p:nvPr/>
         </p:nvSpPr>
         <p:spPr>
           <a:xfrm>
-            <a:off x="804672" y="4977892"/>
-            <a:ext cx="10582351" cy="6350"/>
+            <a:off x="941832" y="5252212"/>
+            <a:ext cx="10308031" cy="6350"/>
           </a:xfrm>
           <a:prstGeom prst="rect">
             <a:avLst/>
@@ -7437,13 +8536,13 @@
       </p:sp>
       <p:sp>
         <p:nvSpPr>
-          <p:cNvPr id="13" name="TextBox 12"/>
+          <p:cNvPr id="15" name="TextBox 14"/>
           <p:cNvSpPr txBox="1"/>
           <p:nvPr/>
         </p:nvSpPr>
         <p:spPr>
           <a:xfrm>
-            <a:off x="804672" y="4984242"/>
+            <a:off x="941832" y="5258562"/>
             <a:ext cx="1828800" cy="274320"/>
           </a:xfrm>
           <a:prstGeom prst="rect">
@@ -7472,14 +8571,14 @@
       </p:sp>
       <p:sp>
         <p:nvSpPr>
-          <p:cNvPr id="14" name="TextBox 13"/>
+          <p:cNvPr id="16" name="TextBox 15"/>
           <p:cNvSpPr txBox="1"/>
           <p:nvPr/>
         </p:nvSpPr>
         <p:spPr>
           <a:xfrm>
-            <a:off x="2862072" y="4984242"/>
-            <a:ext cx="8524951" cy="274320"/>
+            <a:off x="2999232" y="5258562"/>
+            <a:ext cx="8250631" cy="274320"/>
           </a:xfrm>
           <a:prstGeom prst="rect">
             <a:avLst/>
@@ -7507,14 +8606,14 @@
       </p:sp>
       <p:sp>
         <p:nvSpPr>
-          <p:cNvPr id="15" name="Rectangle 14"/>
+          <p:cNvPr id="17" name="Rectangle 16"/>
           <p:cNvSpPr/>
           <p:nvPr/>
         </p:nvSpPr>
         <p:spPr>
           <a:xfrm>
-            <a:off x="804672" y="5258562"/>
-            <a:ext cx="10582351" cy="6350"/>
+            <a:off x="941832" y="5532882"/>
+            <a:ext cx="10308031" cy="6350"/>
           </a:xfrm>
           <a:prstGeom prst="rect">
             <a:avLst/>
@@ -7551,13 +8650,13 @@
       </p:sp>
       <p:sp>
         <p:nvSpPr>
-          <p:cNvPr id="16" name="TextBox 15"/>
+          <p:cNvPr id="18" name="TextBox 17"/>
           <p:cNvSpPr txBox="1"/>
           <p:nvPr/>
         </p:nvSpPr>
         <p:spPr>
           <a:xfrm>
-            <a:off x="804672" y="5264912"/>
+            <a:off x="941832" y="5539232"/>
             <a:ext cx="1828800" cy="365760"/>
           </a:xfrm>
           <a:prstGeom prst="rect">
@@ -7586,14 +8685,14 @@
       </p:sp>
       <p:sp>
         <p:nvSpPr>
-          <p:cNvPr id="17" name="TextBox 16"/>
+          <p:cNvPr id="19" name="TextBox 18"/>
           <p:cNvSpPr txBox="1"/>
           <p:nvPr/>
         </p:nvSpPr>
         <p:spPr>
           <a:xfrm>
-            <a:off x="2862072" y="5264912"/>
-            <a:ext cx="8524951" cy="365760"/>
+            <a:off x="2999232" y="5539232"/>
+            <a:ext cx="8250631" cy="365760"/>
           </a:xfrm>
           <a:prstGeom prst="rect">
             <a:avLst/>
@@ -7621,14 +8720,14 @@
       </p:sp>
       <p:sp>
         <p:nvSpPr>
-          <p:cNvPr id="18" name="Rectangle 17"/>
+          <p:cNvPr id="20" name="Rectangle 19"/>
           <p:cNvSpPr/>
           <p:nvPr/>
         </p:nvSpPr>
         <p:spPr>
           <a:xfrm>
-            <a:off x="804672" y="5630672"/>
-            <a:ext cx="10582351" cy="6350"/>
+            <a:off x="941832" y="5904992"/>
+            <a:ext cx="10308031" cy="6350"/>
           </a:xfrm>
           <a:prstGeom prst="rect">
             <a:avLst/>
@@ -7665,13 +8764,13 @@
       </p:sp>
       <p:sp>
         <p:nvSpPr>
-          <p:cNvPr id="19" name="TextBox 18"/>
+          <p:cNvPr id="21" name="TextBox 20"/>
           <p:cNvSpPr txBox="1"/>
           <p:nvPr/>
         </p:nvSpPr>
         <p:spPr>
           <a:xfrm>
-            <a:off x="804672" y="5637022"/>
+            <a:off x="941832" y="5911342"/>
             <a:ext cx="1828800" cy="457200"/>
           </a:xfrm>
           <a:prstGeom prst="rect">
@@ -7700,14 +8799,14 @@
       </p:sp>
       <p:sp>
         <p:nvSpPr>
-          <p:cNvPr id="20" name="TextBox 19"/>
+          <p:cNvPr id="22" name="TextBox 21"/>
           <p:cNvSpPr txBox="1"/>
           <p:nvPr/>
         </p:nvSpPr>
         <p:spPr>
           <a:xfrm>
-            <a:off x="2862072" y="5637022"/>
-            <a:ext cx="8524951" cy="457200"/>
+            <a:off x="2999232" y="5911342"/>
+            <a:ext cx="8250631" cy="457200"/>
           </a:xfrm>
           <a:prstGeom prst="rect">
             <a:avLst/>

</xml_diff>